<commit_message>
update cantos phase 1
</commit_message>
<xml_diff>
--- a/presentations/CANTOS_PPT.pptx
+++ b/presentations/CANTOS_PPT.pptx
@@ -5,7 +5,7 @@
     <p:sldMasterId id="2147483672" r:id="rId4"/>
   </p:sldMasterIdLst>
   <p:notesMasterIdLst>
-    <p:notesMasterId r:id="rId13"/>
+    <p:notesMasterId r:id="rId14"/>
   </p:notesMasterIdLst>
   <p:sldIdLst>
     <p:sldId id="256" r:id="rId5"/>
@@ -15,7 +15,8 @@
     <p:sldId id="262" r:id="rId9"/>
     <p:sldId id="263" r:id="rId10"/>
     <p:sldId id="259" r:id="rId11"/>
-    <p:sldId id="258" r:id="rId12"/>
+    <p:sldId id="264" r:id="rId12"/>
+    <p:sldId id="258" r:id="rId13"/>
   </p:sldIdLst>
   <p:sldSz cx="12192000" cy="6858000"/>
   <p:notesSz cx="6858000" cy="9144000"/>
@@ -4423,8 +4424,8 @@
         </p:nvSpPr>
         <p:spPr>
           <a:xfrm>
-            <a:off x="547439" y="4845456"/>
-            <a:ext cx="10060481" cy="1200329"/>
+            <a:off x="547439" y="4863349"/>
+            <a:ext cx="11176475" cy="1200329"/>
           </a:xfrm>
           <a:prstGeom prst="rect">
             <a:avLst/>
@@ -4437,9 +4438,10 @@
           </a:bodyPr>
           <a:lstStyle/>
           <a:p>
+            <a:pPr algn="just"/>
             <a:r>
               <a:rPr lang="en-US" dirty="0"/>
-              <a:t>Challenge: disease names in clinical trials registry  contain extraneous information, typographical errors, missing values, non-standard nomenclature and other inconsistencies which create barriers for data integration and downstream analysis of the CTR data.</a:t>
+              <a:t>Challenge: disease names, including tumor names in clinical trials registry  contain extraneous information, typographical errors, missing values, non-standard nomenclature and other inconsistencies which create barriers for data integration and downstream analysis of the CTR data.</a:t>
             </a:r>
           </a:p>
           <a:p>
@@ -4501,7 +4503,7 @@
         </p:nvSpPr>
         <p:spPr>
           <a:xfrm>
-            <a:off x="1222053" y="320156"/>
+            <a:off x="79054" y="0"/>
             <a:ext cx="10651402" cy="1143000"/>
           </a:xfrm>
         </p:spPr>
@@ -4511,7 +4513,7 @@
           <a:p>
             <a:r>
               <a:rPr lang="en-US" dirty="0"/>
-              <a:t>Tumor Name Standardization		</a:t>
+              <a:t>Unstandardized tumor names</a:t>
             </a:r>
           </a:p>
         </p:txBody>
@@ -4553,31 +4555,442 @@
           </a:p>
         </p:txBody>
       </p:sp>
-      <p:sp>
-        <p:nvSpPr>
-          <p:cNvPr id="6" name="Content Placeholder 5">
-            <a:extLst>
-              <a:ext uri="{FF2B5EF4-FFF2-40B4-BE49-F238E27FC236}">
-                <a16:creationId xmlns:a16="http://schemas.microsoft.com/office/drawing/2014/main" id="{69E5054C-30A8-2747-5DB5-31260516A80B}"/>
-              </a:ext>
-            </a:extLst>
-          </p:cNvPr>
-          <p:cNvSpPr>
-            <a:spLocks noGrp="1"/>
-          </p:cNvSpPr>
+      <p:graphicFrame>
+        <p:nvGraphicFramePr>
+          <p:cNvPr id="7" name="Table 6">
+            <a:extLst>
+              <a:ext uri="{FF2B5EF4-FFF2-40B4-BE49-F238E27FC236}">
+                <a16:creationId xmlns:a16="http://schemas.microsoft.com/office/drawing/2014/main" id="{1782C44F-99F5-A0A7-BC97-FD48AD99745C}"/>
+              </a:ext>
+            </a:extLst>
+          </p:cNvPr>
+          <p:cNvGraphicFramePr>
+            <a:graphicFrameLocks noGrp="1"/>
+          </p:cNvGraphicFramePr>
           <p:nvPr>
-            <p:ph idx="1"/>
+            <p:extLst>
+              <p:ext uri="{D42A27DB-BD31-4B8C-83A1-F6EECF244321}">
+                <p14:modId xmlns:p14="http://schemas.microsoft.com/office/powerpoint/2010/main" val="1719294777"/>
+              </p:ext>
+            </p:extLst>
           </p:nvPr>
-        </p:nvSpPr>
-        <p:spPr/>
-        <p:txBody>
-          <a:bodyPr/>
-          <a:lstStyle/>
-          <a:p>
-            <a:endParaRPr lang="en-US"/>
-          </a:p>
-        </p:txBody>
-      </p:sp>
+        </p:nvGraphicFramePr>
+        <p:xfrm>
+          <a:off x="1461544" y="1143000"/>
+          <a:ext cx="8994814" cy="3655156"/>
+        </p:xfrm>
+        <a:graphic>
+          <a:graphicData uri="http://schemas.openxmlformats.org/drawingml/2006/table">
+            <a:tbl>
+              <a:tblPr firstRow="1" bandRow="1">
+                <a:tableStyleId>{5C22544A-7EE6-4342-B048-85BDC9FD1C3A}</a:tableStyleId>
+              </a:tblPr>
+              <a:tblGrid>
+                <a:gridCol w="3087617">
+                  <a:extLst>
+                    <a:ext uri="{9D8B030D-6E8A-4147-A177-3AD203B41FA5}">
+                      <a16:colId xmlns:a16="http://schemas.microsoft.com/office/drawing/2014/main" val="1106209466"/>
+                    </a:ext>
+                  </a:extLst>
+                </a:gridCol>
+                <a:gridCol w="3019280">
+                  <a:extLst>
+                    <a:ext uri="{9D8B030D-6E8A-4147-A177-3AD203B41FA5}">
+                      <a16:colId xmlns:a16="http://schemas.microsoft.com/office/drawing/2014/main" val="1462595529"/>
+                    </a:ext>
+                  </a:extLst>
+                </a:gridCol>
+                <a:gridCol w="2887917">
+                  <a:extLst>
+                    <a:ext uri="{9D8B030D-6E8A-4147-A177-3AD203B41FA5}">
+                      <a16:colId xmlns:a16="http://schemas.microsoft.com/office/drawing/2014/main" val="242162575"/>
+                    </a:ext>
+                  </a:extLst>
+                </a:gridCol>
+              </a:tblGrid>
+              <a:tr h="472978">
+                <a:tc>
+                  <a:txBody>
+                    <a:bodyPr/>
+                    <a:lstStyle/>
+                    <a:p>
+                      <a:r>
+                        <a:rPr lang="en-US" dirty="0"/>
+                        <a:t>CT Tumor Names</a:t>
+                      </a:r>
+                    </a:p>
+                  </a:txBody>
+                  <a:tcPr/>
+                </a:tc>
+                <a:tc>
+                  <a:txBody>
+                    <a:bodyPr/>
+                    <a:lstStyle/>
+                    <a:p>
+                      <a:r>
+                        <a:rPr lang="en-US" dirty="0"/>
+                        <a:t>Issues</a:t>
+                      </a:r>
+                    </a:p>
+                  </a:txBody>
+                  <a:tcPr/>
+                </a:tc>
+                <a:tc>
+                  <a:txBody>
+                    <a:bodyPr/>
+                    <a:lstStyle/>
+                    <a:p>
+                      <a:r>
+                        <a:rPr lang="en-US" dirty="0"/>
+                        <a:t>WHO Standard Names</a:t>
+                      </a:r>
+                    </a:p>
+                  </a:txBody>
+                  <a:tcPr/>
+                </a:tc>
+                <a:extLst>
+                  <a:ext uri="{0D108BD9-81ED-4DB2-BD59-A6C34878D82A}">
+                    <a16:rowId xmlns:a16="http://schemas.microsoft.com/office/drawing/2014/main" val="1751357925"/>
+                  </a:ext>
+                </a:extLst>
+              </a:tr>
+              <a:tr h="457554">
+                <a:tc>
+                  <a:txBody>
+                    <a:bodyPr/>
+                    <a:lstStyle/>
+                    <a:p>
+                      <a:r>
+                        <a:rPr lang="en-US" sz="1400" dirty="0"/>
+                        <a:t>acute myeloid </a:t>
+                      </a:r>
+                      <a:r>
+                        <a:rPr lang="en-US" sz="1400" dirty="0" err="1"/>
+                        <a:t>leucaemia</a:t>
+                      </a:r>
+                      <a:endParaRPr lang="en-US" sz="1400" dirty="0"/>
+                    </a:p>
+                  </a:txBody>
+                  <a:tcPr/>
+                </a:tc>
+                <a:tc>
+                  <a:txBody>
+                    <a:bodyPr/>
+                    <a:lstStyle/>
+                    <a:p>
+                      <a:r>
+                        <a:rPr lang="en-US" sz="1400" dirty="0" err="1"/>
+                        <a:t>Leukaemia</a:t>
+                      </a:r>
+                      <a:r>
+                        <a:rPr lang="en-US" sz="1400" dirty="0"/>
+                        <a:t> not spelled correctly </a:t>
+                      </a:r>
+                    </a:p>
+                  </a:txBody>
+                  <a:tcPr/>
+                </a:tc>
+                <a:tc>
+                  <a:txBody>
+                    <a:bodyPr/>
+                    <a:lstStyle/>
+                    <a:p>
+                      <a:r>
+                        <a:rPr lang="en-US" sz="1400" dirty="0">
+                          <a:effectLst/>
+                        </a:rPr>
+                        <a:t>acute myeloid </a:t>
+                      </a:r>
+                      <a:r>
+                        <a:rPr lang="en-US" sz="1400" dirty="0" err="1">
+                          <a:effectLst/>
+                        </a:rPr>
+                        <a:t>leukaemia</a:t>
+                      </a:r>
+                      <a:endParaRPr lang="en-US" sz="1400" dirty="0">
+                        <a:effectLst/>
+                      </a:endParaRPr>
+                    </a:p>
+                  </a:txBody>
+                  <a:tcPr marL="47625" marR="47625" marT="38100" marB="38100" anchor="ctr"/>
+                </a:tc>
+                <a:extLst>
+                  <a:ext uri="{0D108BD9-81ED-4DB2-BD59-A6C34878D82A}">
+                    <a16:rowId xmlns:a16="http://schemas.microsoft.com/office/drawing/2014/main" val="65510083"/>
+                  </a:ext>
+                </a:extLst>
+              </a:tr>
+              <a:tr h="708487">
+                <a:tc>
+                  <a:txBody>
+                    <a:bodyPr/>
+                    <a:lstStyle/>
+                    <a:p>
+                      <a:r>
+                        <a:rPr lang="en-US" sz="1400" dirty="0"/>
+                        <a:t>glioblastoma or solid tumors, epidermal growth factor receptor (</a:t>
+                      </a:r>
+                      <a:r>
+                        <a:rPr lang="en-US" sz="1400" dirty="0" err="1"/>
+                        <a:t>egfr</a:t>
+                      </a:r>
+                      <a:r>
+                        <a:rPr lang="en-US" sz="1400" dirty="0"/>
+                        <a:t>) diagnosis</a:t>
+                      </a:r>
+                    </a:p>
+                    <a:p>
+                      <a:endParaRPr lang="en-US" sz="1400" dirty="0"/>
+                    </a:p>
+                  </a:txBody>
+                  <a:tcPr/>
+                </a:tc>
+                <a:tc>
+                  <a:txBody>
+                    <a:bodyPr/>
+                    <a:lstStyle/>
+                    <a:p>
+                      <a:r>
+                        <a:rPr lang="en-US" sz="1400" dirty="0"/>
+                        <a:t>Has two types of tumor: glioblastoma and solid tumors, extra information on  EGFR</a:t>
+                      </a:r>
+                    </a:p>
+                  </a:txBody>
+                  <a:tcPr/>
+                </a:tc>
+                <a:tc>
+                  <a:txBody>
+                    <a:bodyPr/>
+                    <a:lstStyle/>
+                    <a:p>
+                      <a:r>
+                        <a:rPr lang="en-US" sz="1400" dirty="0"/>
+                        <a:t>glioblastoma, </a:t>
+                      </a:r>
+                      <a:r>
+                        <a:rPr lang="en-US" sz="1400" dirty="0" err="1"/>
+                        <a:t>idh</a:t>
+                      </a:r>
+                      <a:r>
+                        <a:rPr lang="en-US" sz="1400" dirty="0"/>
+                        <a:t>-wildtype</a:t>
+                      </a:r>
+                    </a:p>
+                  </a:txBody>
+                  <a:tcPr/>
+                </a:tc>
+                <a:extLst>
+                  <a:ext uri="{0D108BD9-81ED-4DB2-BD59-A6C34878D82A}">
+                    <a16:rowId xmlns:a16="http://schemas.microsoft.com/office/drawing/2014/main" val="1041037533"/>
+                  </a:ext>
+                </a:extLst>
+              </a:tr>
+              <a:tr h="500866">
+                <a:tc>
+                  <a:txBody>
+                    <a:bodyPr/>
+                    <a:lstStyle/>
+                    <a:p>
+                      <a:r>
+                        <a:rPr lang="en-US" sz="1400" dirty="0">
+                          <a:effectLst/>
+                        </a:rPr>
+                        <a:t>pathologic stage </a:t>
+                      </a:r>
+                      <a:r>
+                        <a:rPr lang="en-US" sz="1400" dirty="0" err="1">
+                          <a:effectLst/>
+                        </a:rPr>
+                        <a:t>i</a:t>
+                      </a:r>
+                      <a:r>
+                        <a:rPr lang="en-US" sz="1400" dirty="0">
+                          <a:effectLst/>
+                        </a:rPr>
+                        <a:t> </a:t>
+                      </a:r>
+                      <a:r>
+                        <a:rPr lang="en-US" sz="1400" dirty="0" err="1">
+                          <a:effectLst/>
+                        </a:rPr>
+                        <a:t>merkel</a:t>
+                      </a:r>
+                      <a:r>
+                        <a:rPr lang="en-US" sz="1400" dirty="0">
+                          <a:effectLst/>
+                        </a:rPr>
+                        <a:t> cell carcinoma </a:t>
+                      </a:r>
+                      <a:r>
+                        <a:rPr lang="en-US" sz="1400" dirty="0" err="1">
+                          <a:effectLst/>
+                        </a:rPr>
+                        <a:t>ajcc</a:t>
+                      </a:r>
+                      <a:r>
+                        <a:rPr lang="en-US" sz="1400" dirty="0">
+                          <a:effectLst/>
+                        </a:rPr>
+                        <a:t> v8</a:t>
+                      </a:r>
+                    </a:p>
+                  </a:txBody>
+                  <a:tcPr marL="47625" marR="47625" marT="38100" marB="38100" anchor="ctr"/>
+                </a:tc>
+                <a:tc>
+                  <a:txBody>
+                    <a:bodyPr/>
+                    <a:lstStyle/>
+                    <a:p>
+                      <a:r>
+                        <a:rPr lang="en-US" sz="1400" dirty="0">
+                          <a:effectLst/>
+                        </a:rPr>
+                        <a:t>extra information on staging</a:t>
+                      </a:r>
+                    </a:p>
+                  </a:txBody>
+                  <a:tcPr marL="47625" marR="47625" marT="38100" marB="38100" anchor="ctr"/>
+                </a:tc>
+                <a:tc>
+                  <a:txBody>
+                    <a:bodyPr/>
+                    <a:lstStyle/>
+                    <a:p>
+                      <a:r>
+                        <a:rPr lang="en-US" sz="1400" dirty="0" err="1">
+                          <a:effectLst/>
+                        </a:rPr>
+                        <a:t>merkel</a:t>
+                      </a:r>
+                      <a:r>
+                        <a:rPr lang="en-US" sz="1400" dirty="0">
+                          <a:effectLst/>
+                        </a:rPr>
+                        <a:t> cell carcinoma</a:t>
+                      </a:r>
+                    </a:p>
+                  </a:txBody>
+                  <a:tcPr marL="47625" marR="47625" marT="38100" marB="38100" anchor="ctr"/>
+                </a:tc>
+                <a:extLst>
+                  <a:ext uri="{0D108BD9-81ED-4DB2-BD59-A6C34878D82A}">
+                    <a16:rowId xmlns:a16="http://schemas.microsoft.com/office/drawing/2014/main" val="3070337974"/>
+                  </a:ext>
+                </a:extLst>
+              </a:tr>
+              <a:tr h="545304">
+                <a:tc>
+                  <a:txBody>
+                    <a:bodyPr/>
+                    <a:lstStyle/>
+                    <a:p>
+                      <a:r>
+                        <a:rPr lang="en-US" sz="1400" dirty="0">
+                          <a:effectLst/>
+                        </a:rPr>
+                        <a:t>adrenocortical carcinoma (part g)</a:t>
+                      </a:r>
+                    </a:p>
+                  </a:txBody>
+                  <a:tcPr marL="47625" marR="47625" marT="38100" marB="38100" anchor="ctr"/>
+                </a:tc>
+                <a:tc>
+                  <a:txBody>
+                    <a:bodyPr/>
+                    <a:lstStyle/>
+                    <a:p>
+                      <a:r>
+                        <a:rPr lang="en-US" sz="1400" dirty="0">
+                          <a:effectLst/>
+                        </a:rPr>
+                        <a:t> Extra information in bracket</a:t>
+                      </a:r>
+                    </a:p>
+                  </a:txBody>
+                  <a:tcPr marL="47625" marR="47625" marT="38100" marB="38100" anchor="ctr"/>
+                </a:tc>
+                <a:tc>
+                  <a:txBody>
+                    <a:bodyPr/>
+                    <a:lstStyle/>
+                    <a:p>
+                      <a:r>
+                        <a:rPr lang="en-US" sz="1400" dirty="0">
+                          <a:effectLst/>
+                        </a:rPr>
+                        <a:t> adrenal cortical carcinoma</a:t>
+                      </a:r>
+                    </a:p>
+                  </a:txBody>
+                  <a:tcPr marL="47625" marR="47625" marT="38100" marB="38100" anchor="ctr"/>
+                </a:tc>
+                <a:extLst>
+                  <a:ext uri="{0D108BD9-81ED-4DB2-BD59-A6C34878D82A}">
+                    <a16:rowId xmlns:a16="http://schemas.microsoft.com/office/drawing/2014/main" val="2004295928"/>
+                  </a:ext>
+                </a:extLst>
+              </a:tr>
+              <a:tr h="708487">
+                <a:tc>
+                  <a:txBody>
+                    <a:bodyPr/>
+                    <a:lstStyle/>
+                    <a:p>
+                      <a:r>
+                        <a:rPr lang="en-US" sz="1400" dirty="0" err="1"/>
+                        <a:t>ann</a:t>
+                      </a:r>
+                      <a:r>
+                        <a:rPr lang="en-US" sz="1400" dirty="0"/>
+                        <a:t> arbor stage iii diffuse large b-cell lymphoma</a:t>
+                      </a:r>
+                    </a:p>
+                    <a:p>
+                      <a:endParaRPr lang="en-US" sz="1400" dirty="0"/>
+                    </a:p>
+                  </a:txBody>
+                  <a:tcPr/>
+                </a:tc>
+                <a:tc>
+                  <a:txBody>
+                    <a:bodyPr/>
+                    <a:lstStyle/>
+                    <a:p>
+                      <a:r>
+                        <a:rPr lang="en-US" sz="1400" dirty="0"/>
+                        <a:t> extra information on staging </a:t>
+                      </a:r>
+                    </a:p>
+                  </a:txBody>
+                  <a:tcPr/>
+                </a:tc>
+                <a:tc>
+                  <a:txBody>
+                    <a:bodyPr/>
+                    <a:lstStyle/>
+                    <a:p>
+                      <a:r>
+                        <a:rPr lang="en-US" sz="1400" dirty="0"/>
+                        <a:t>diffuse large b-cell lymphoma</a:t>
+                      </a:r>
+                    </a:p>
+                    <a:p>
+                      <a:endParaRPr lang="en-US" sz="1400" dirty="0"/>
+                    </a:p>
+                  </a:txBody>
+                  <a:tcPr/>
+                </a:tc>
+                <a:extLst>
+                  <a:ext uri="{0D108BD9-81ED-4DB2-BD59-A6C34878D82A}">
+                    <a16:rowId xmlns:a16="http://schemas.microsoft.com/office/drawing/2014/main" val="3939223885"/>
+                  </a:ext>
+                </a:extLst>
+              </a:tr>
+            </a:tbl>
+          </a:graphicData>
+        </a:graphic>
+      </p:graphicFrame>
     </p:spTree>
     <p:extLst>
       <p:ext uri="{BB962C8B-B14F-4D97-AF65-F5344CB8AC3E}">
@@ -4596,6 +5009,291 @@
   <p:cSld>
     <p:spTree>
       <p:nvGrpSpPr>
+        <p:cNvPr id="1" name="">
+          <a:extLst>
+            <a:ext uri="{FF2B5EF4-FFF2-40B4-BE49-F238E27FC236}">
+              <a16:creationId xmlns:a16="http://schemas.microsoft.com/office/drawing/2014/main" id="{2A01996C-AEFF-C3A9-751E-CB258B5285F7}"/>
+            </a:ext>
+          </a:extLst>
+        </p:cNvPr>
+        <p:cNvGrpSpPr/>
+        <p:nvPr/>
+      </p:nvGrpSpPr>
+      <p:grpSpPr>
+        <a:xfrm>
+          <a:off x="0" y="0"/>
+          <a:ext cx="0" cy="0"/>
+          <a:chOff x="0" y="0"/>
+          <a:chExt cx="0" cy="0"/>
+        </a:xfrm>
+      </p:grpSpPr>
+      <p:sp>
+        <p:nvSpPr>
+          <p:cNvPr id="2" name="Title 1">
+            <a:extLst>
+              <a:ext uri="{FF2B5EF4-FFF2-40B4-BE49-F238E27FC236}">
+                <a16:creationId xmlns:a16="http://schemas.microsoft.com/office/drawing/2014/main" id="{273A313D-6D6A-BE2B-263D-27E5BA15AEB2}"/>
+              </a:ext>
+            </a:extLst>
+          </p:cNvPr>
+          <p:cNvSpPr>
+            <a:spLocks noGrp="1"/>
+          </p:cNvSpPr>
+          <p:nvPr>
+            <p:ph type="title"/>
+          </p:nvPr>
+        </p:nvSpPr>
+        <p:spPr>
+          <a:xfrm>
+            <a:off x="87086" y="21771"/>
+            <a:ext cx="10651402" cy="1143000"/>
+          </a:xfrm>
+        </p:spPr>
+        <p:txBody>
+          <a:bodyPr/>
+          <a:lstStyle/>
+          <a:p>
+            <a:r>
+              <a:rPr lang="en-US" dirty="0"/>
+              <a:t>Tumor Name Standardization		</a:t>
+            </a:r>
+          </a:p>
+        </p:txBody>
+      </p:sp>
+      <p:sp>
+        <p:nvSpPr>
+          <p:cNvPr id="3" name="Content Placeholder 2">
+            <a:extLst>
+              <a:ext uri="{FF2B5EF4-FFF2-40B4-BE49-F238E27FC236}">
+                <a16:creationId xmlns:a16="http://schemas.microsoft.com/office/drawing/2014/main" id="{7D082753-632D-7BBE-C9E9-F9AE285F5C75}"/>
+              </a:ext>
+            </a:extLst>
+          </p:cNvPr>
+          <p:cNvSpPr>
+            <a:spLocks noGrp="1"/>
+          </p:cNvSpPr>
+          <p:nvPr>
+            <p:ph idx="1"/>
+          </p:nvPr>
+        </p:nvSpPr>
+        <p:spPr>
+          <a:xfrm>
+            <a:off x="179670" y="1164771"/>
+            <a:ext cx="11261215" cy="4484914"/>
+          </a:xfrm>
+        </p:spPr>
+        <p:txBody>
+          <a:bodyPr>
+            <a:normAutofit/>
+          </a:bodyPr>
+          <a:lstStyle/>
+          <a:p>
+            <a:pPr algn="just"/>
+            <a:r>
+              <a:rPr lang="en-US" sz="1800" dirty="0">
+                <a:solidFill>
+                  <a:schemeClr val="tx1"/>
+                </a:solidFill>
+                <a:latin typeface="+mn-lt"/>
+                <a:cs typeface="+mn-cs"/>
+              </a:rPr>
+              <a:t> We aimed to standardize tumor names contained in CTR. Tumor names represent a significant proportion of condition names in CTR.</a:t>
+            </a:r>
+          </a:p>
+          <a:p>
+            <a:pPr algn="just"/>
+            <a:endParaRPr lang="en-US" sz="1800" dirty="0">
+              <a:solidFill>
+                <a:schemeClr val="tx1"/>
+              </a:solidFill>
+              <a:latin typeface="+mn-lt"/>
+              <a:cs typeface="+mn-cs"/>
+            </a:endParaRPr>
+          </a:p>
+          <a:p>
+            <a:pPr algn="just"/>
+            <a:r>
+              <a:rPr lang="en-US" sz="1800" dirty="0">
+                <a:solidFill>
+                  <a:schemeClr val="tx1"/>
+                </a:solidFill>
+                <a:latin typeface="+mn-lt"/>
+                <a:cs typeface="+mn-cs"/>
+              </a:rPr>
+              <a:t>Unlike other condition names, for tumor names , we have the WHO tumor classification system which is accepted as the gold standard for tumor nomenclature among clinicians. Also, other databases such as the </a:t>
+            </a:r>
+            <a:r>
+              <a:rPr lang="en-US" sz="1800" dirty="0" err="1">
+                <a:solidFill>
+                  <a:schemeClr val="tx1"/>
+                </a:solidFill>
+                <a:latin typeface="+mn-lt"/>
+                <a:cs typeface="+mn-cs"/>
+              </a:rPr>
+              <a:t>NCIt</a:t>
+            </a:r>
+            <a:r>
+              <a:rPr lang="en-US" sz="1800" dirty="0">
+                <a:solidFill>
+                  <a:schemeClr val="tx1"/>
+                </a:solidFill>
+                <a:latin typeface="+mn-lt"/>
+                <a:cs typeface="+mn-cs"/>
+              </a:rPr>
+              <a:t> (National Cancer Institute Thesaurus) have standardized tumor nomenclature. </a:t>
+            </a:r>
+          </a:p>
+          <a:p>
+            <a:pPr algn="just"/>
+            <a:endParaRPr lang="en-US" sz="1800" dirty="0">
+              <a:solidFill>
+                <a:schemeClr val="tx1"/>
+              </a:solidFill>
+              <a:latin typeface="+mn-lt"/>
+              <a:cs typeface="+mn-cs"/>
+            </a:endParaRPr>
+          </a:p>
+          <a:p>
+            <a:pPr algn="just"/>
+            <a:r>
+              <a:rPr lang="en-US" sz="1800" dirty="0">
+                <a:solidFill>
+                  <a:schemeClr val="tx1"/>
+                </a:solidFill>
+                <a:latin typeface="+mn-lt"/>
+                <a:cs typeface="+mn-cs"/>
+              </a:rPr>
+              <a:t>A standardized system for tumor nomenclature provides us with a reference for mapping unstandardized tumor names from CTR and a basis for evaluating any method that performs this mapping.</a:t>
+            </a:r>
+          </a:p>
+          <a:p>
+            <a:pPr algn="just"/>
+            <a:endParaRPr lang="en-US" sz="1800" dirty="0">
+              <a:solidFill>
+                <a:schemeClr val="tx1"/>
+              </a:solidFill>
+              <a:latin typeface="+mn-lt"/>
+              <a:cs typeface="+mn-cs"/>
+            </a:endParaRPr>
+          </a:p>
+          <a:p>
+            <a:pPr algn="just"/>
+            <a:r>
+              <a:rPr lang="en-US" sz="1800" dirty="0">
+                <a:solidFill>
+                  <a:schemeClr val="tx1"/>
+                </a:solidFill>
+                <a:latin typeface="+mn-lt"/>
+                <a:cs typeface="+mn-cs"/>
+              </a:rPr>
+              <a:t>To this end, we developed the CANTOS (Clinical trials Automated Nomenclature and Tumor Ontology Standardization) pipeline to extract tumor names from CTR and standardize them with respect to the WHO tumor classification system and </a:t>
+            </a:r>
+            <a:r>
+              <a:rPr lang="en-US" sz="1800" dirty="0" err="1">
+                <a:solidFill>
+                  <a:schemeClr val="tx1"/>
+                </a:solidFill>
+                <a:latin typeface="+mn-lt"/>
+                <a:cs typeface="+mn-cs"/>
+              </a:rPr>
+              <a:t>NCIt</a:t>
+            </a:r>
+            <a:r>
+              <a:rPr lang="en-US" sz="1800" dirty="0">
+                <a:solidFill>
+                  <a:schemeClr val="tx1"/>
+                </a:solidFill>
+                <a:latin typeface="+mn-lt"/>
+                <a:cs typeface="+mn-cs"/>
+              </a:rPr>
+              <a:t> database</a:t>
+            </a:r>
+            <a:r>
+              <a:rPr lang="en-US" sz="1800" dirty="0">
+                <a:solidFill>
+                  <a:srgbClr val="000000"/>
+                </a:solidFill>
+                <a:latin typeface="Times New Roman" panose="02020603050405020304" pitchFamily="18" charset="0"/>
+              </a:rPr>
+              <a:t>. </a:t>
+            </a:r>
+          </a:p>
+          <a:p>
+            <a:endParaRPr lang="en-US" sz="1800" dirty="0">
+              <a:solidFill>
+                <a:srgbClr val="000000"/>
+              </a:solidFill>
+              <a:latin typeface="Times New Roman" panose="02020603050405020304" pitchFamily="18" charset="0"/>
+            </a:endParaRPr>
+          </a:p>
+          <a:p>
+            <a:endParaRPr lang="en-US" sz="1800" dirty="0">
+              <a:solidFill>
+                <a:srgbClr val="000000"/>
+              </a:solidFill>
+              <a:latin typeface="Times New Roman" panose="02020603050405020304" pitchFamily="18" charset="0"/>
+            </a:endParaRPr>
+          </a:p>
+          <a:p>
+            <a:endParaRPr lang="en-US" dirty="0"/>
+          </a:p>
+        </p:txBody>
+      </p:sp>
+      <p:sp>
+        <p:nvSpPr>
+          <p:cNvPr id="4" name="Slide Number Placeholder 3">
+            <a:extLst>
+              <a:ext uri="{FF2B5EF4-FFF2-40B4-BE49-F238E27FC236}">
+                <a16:creationId xmlns:a16="http://schemas.microsoft.com/office/drawing/2014/main" id="{874865C2-BF25-6030-3F39-CD518B0D06B9}"/>
+              </a:ext>
+            </a:extLst>
+          </p:cNvPr>
+          <p:cNvSpPr>
+            <a:spLocks noGrp="1"/>
+          </p:cNvSpPr>
+          <p:nvPr>
+            <p:ph type="sldNum" sz="quarter" idx="12"/>
+          </p:nvPr>
+        </p:nvSpPr>
+        <p:spPr/>
+        <p:txBody>
+          <a:bodyPr/>
+          <a:lstStyle/>
+          <a:p>
+            <a:fld id="{AD40181A-01B0-4CB8-8614-1473649F6741}" type="slidenum">
+              <a:rPr lang="en-US" smtClean="0">
+                <a:solidFill>
+                  <a:schemeClr val="bg1"/>
+                </a:solidFill>
+              </a:rPr>
+              <a:t>8</a:t>
+            </a:fld>
+            <a:endParaRPr lang="en-US" dirty="0">
+              <a:solidFill>
+                <a:schemeClr val="bg1"/>
+              </a:solidFill>
+            </a:endParaRPr>
+          </a:p>
+        </p:txBody>
+      </p:sp>
+    </p:spTree>
+    <p:extLst>
+      <p:ext uri="{BB962C8B-B14F-4D97-AF65-F5344CB8AC3E}">
+        <p14:creationId xmlns:p14="http://schemas.microsoft.com/office/powerpoint/2010/main" val="579408319"/>
+      </p:ext>
+    </p:extLst>
+  </p:cSld>
+  <p:clrMapOvr>
+    <a:masterClrMapping/>
+  </p:clrMapOvr>
+</p:sld>
+</file>
+
+<file path=ppt/slides/slide9.xml><?xml version="1.0" encoding="utf-8"?>
+<p:sld xmlns:a="http://schemas.openxmlformats.org/drawingml/2006/main" xmlns:r="http://schemas.openxmlformats.org/officeDocument/2006/relationships" xmlns:p="http://schemas.openxmlformats.org/presentationml/2006/main">
+  <p:cSld>
+    <p:spTree>
+      <p:nvGrpSpPr>
         <p:cNvPr id="1" name=""/>
         <p:cNvGrpSpPr/>
         <p:nvPr/>
@@ -4629,7 +5327,7 @@
                   <a:srgbClr val="FFFFFE"/>
                 </a:solidFill>
               </a:rPr>
-              <a:t>8</a:t>
+              <a:t>9</a:t>
             </a:fld>
             <a:endParaRPr lang="en-US" dirty="0">
               <a:solidFill>
@@ -4651,14 +5349,613 @@
         </p:nvSpPr>
         <p:spPr>
           <a:xfrm>
-            <a:off x="118101" y="99178"/>
-            <a:ext cx="9753600" cy="1444752"/>
+            <a:off x="0" y="-294409"/>
+            <a:ext cx="11660242" cy="1272422"/>
           </a:xfrm>
         </p:spPr>
         <p:txBody>
           <a:bodyPr/>
           <a:lstStyle/>
           <a:p>
+            <a:r>
+              <a:rPr lang="en-US" dirty="0"/>
+              <a:t>CANTOS : Tumor identification phase</a:t>
+            </a:r>
+          </a:p>
+        </p:txBody>
+      </p:sp>
+      <p:pic>
+        <p:nvPicPr>
+          <p:cNvPr id="4" name="Content Placeholder 8" descr="A blue and black logo&#10;&#10;Description automatically generated">
+            <a:extLst>
+              <a:ext uri="{FF2B5EF4-FFF2-40B4-BE49-F238E27FC236}">
+                <a16:creationId xmlns:a16="http://schemas.microsoft.com/office/drawing/2014/main" id="{19C3A9C1-93F1-99D1-8570-48F0B1D01BD1}"/>
+              </a:ext>
+            </a:extLst>
+          </p:cNvPr>
+          <p:cNvPicPr>
+            <a:picLocks noChangeAspect="1"/>
+          </p:cNvPicPr>
+          <p:nvPr/>
+        </p:nvPicPr>
+        <p:blipFill>
+          <a:blip r:embed="rId2"/>
+          <a:stretch>
+            <a:fillRect/>
+          </a:stretch>
+        </p:blipFill>
+        <p:spPr>
+          <a:xfrm>
+            <a:off x="307654" y="2337770"/>
+            <a:ext cx="1782457" cy="1433858"/>
+          </a:xfrm>
+          <a:prstGeom prst="rect">
+            <a:avLst/>
+          </a:prstGeom>
+        </p:spPr>
+      </p:pic>
+      <p:pic>
+        <p:nvPicPr>
+          <p:cNvPr id="5" name="Graphic 4" descr="Document outline">
+            <a:extLst>
+              <a:ext uri="{FF2B5EF4-FFF2-40B4-BE49-F238E27FC236}">
+                <a16:creationId xmlns:a16="http://schemas.microsoft.com/office/drawing/2014/main" id="{35DFDB22-5FF4-65DD-75A8-BA8476C1E73C}"/>
+              </a:ext>
+            </a:extLst>
+          </p:cNvPr>
+          <p:cNvPicPr>
+            <a:picLocks noChangeAspect="1"/>
+          </p:cNvPicPr>
+          <p:nvPr/>
+        </p:nvPicPr>
+        <p:blipFill>
+          <a:blip r:embed="rId3">
+            <a:extLst>
+              <a:ext uri="{96DAC541-7B7A-43D3-8B79-37D633B846F1}">
+                <asvg:svgBlip xmlns:asvg="http://schemas.microsoft.com/office/drawing/2016/SVG/main" r:embed="rId4"/>
+              </a:ext>
+            </a:extLst>
+          </a:blip>
+          <a:stretch>
+            <a:fillRect/>
+          </a:stretch>
+        </p:blipFill>
+        <p:spPr>
+          <a:xfrm>
+            <a:off x="3361564" y="2241763"/>
+            <a:ext cx="1122081" cy="1122081"/>
+          </a:xfrm>
+          <a:prstGeom prst="rect">
+            <a:avLst/>
+          </a:prstGeom>
+        </p:spPr>
+      </p:pic>
+      <p:sp>
+        <p:nvSpPr>
+          <p:cNvPr id="7" name="TextBox 6">
+            <a:extLst>
+              <a:ext uri="{FF2B5EF4-FFF2-40B4-BE49-F238E27FC236}">
+                <a16:creationId xmlns:a16="http://schemas.microsoft.com/office/drawing/2014/main" id="{679CA8DB-EE78-BB29-19B5-1FAA56F5D1ED}"/>
+              </a:ext>
+            </a:extLst>
+          </p:cNvPr>
+          <p:cNvSpPr txBox="1"/>
+          <p:nvPr/>
+        </p:nvSpPr>
+        <p:spPr>
+          <a:xfrm>
+            <a:off x="3238585" y="3316516"/>
+            <a:ext cx="1598515" cy="369332"/>
+          </a:xfrm>
+          <a:prstGeom prst="rect">
+            <a:avLst/>
+          </a:prstGeom>
+          <a:noFill/>
+        </p:spPr>
+        <p:txBody>
+          <a:bodyPr wrap="none" rtlCol="0">
+            <a:spAutoFit/>
+          </a:bodyPr>
+          <a:lstStyle/>
+          <a:p>
+            <a:r>
+              <a:rPr lang="en-US" dirty="0" err="1">
+                <a:solidFill>
+                  <a:schemeClr val="bg2">
+                    <a:lumMod val="50000"/>
+                  </a:schemeClr>
+                </a:solidFill>
+              </a:rPr>
+              <a:t>conditions.txt</a:t>
+            </a:r>
+            <a:endParaRPr lang="en-US" dirty="0">
+              <a:solidFill>
+                <a:schemeClr val="bg2">
+                  <a:lumMod val="50000"/>
+                </a:schemeClr>
+              </a:solidFill>
+            </a:endParaRPr>
+          </a:p>
+        </p:txBody>
+      </p:sp>
+      <p:sp>
+        <p:nvSpPr>
+          <p:cNvPr id="8" name="Right Arrow 7">
+            <a:extLst>
+              <a:ext uri="{FF2B5EF4-FFF2-40B4-BE49-F238E27FC236}">
+                <a16:creationId xmlns:a16="http://schemas.microsoft.com/office/drawing/2014/main" id="{9F1004FD-3068-A67A-3EC2-49B333972427}"/>
+              </a:ext>
+            </a:extLst>
+          </p:cNvPr>
+          <p:cNvSpPr/>
+          <p:nvPr/>
+        </p:nvSpPr>
+        <p:spPr>
+          <a:xfrm>
+            <a:off x="2213090" y="2642314"/>
+            <a:ext cx="1025495" cy="529839"/>
+          </a:xfrm>
+          <a:prstGeom prst="rightArrow">
+            <a:avLst/>
+          </a:prstGeom>
+        </p:spPr>
+        <p:style>
+          <a:lnRef idx="2">
+            <a:schemeClr val="accent1">
+              <a:shade val="15000"/>
+            </a:schemeClr>
+          </a:lnRef>
+          <a:fillRef idx="1">
+            <a:schemeClr val="accent1"/>
+          </a:fillRef>
+          <a:effectRef idx="0">
+            <a:schemeClr val="accent1"/>
+          </a:effectRef>
+          <a:fontRef idx="minor">
+            <a:schemeClr val="lt1"/>
+          </a:fontRef>
+        </p:style>
+        <p:txBody>
+          <a:bodyPr rtlCol="0" anchor="ctr"/>
+          <a:lstStyle/>
+          <a:p>
+            <a:pPr algn="ctr"/>
+            <a:endParaRPr lang="en-US"/>
+          </a:p>
+        </p:txBody>
+      </p:sp>
+      <p:sp>
+        <p:nvSpPr>
+          <p:cNvPr id="11" name="Rectangle 10">
+            <a:extLst>
+              <a:ext uri="{FF2B5EF4-FFF2-40B4-BE49-F238E27FC236}">
+                <a16:creationId xmlns:a16="http://schemas.microsoft.com/office/drawing/2014/main" id="{88D1C32A-F598-2AFF-5354-C13FA1267869}"/>
+              </a:ext>
+            </a:extLst>
+          </p:cNvPr>
+          <p:cNvSpPr/>
+          <p:nvPr/>
+        </p:nvSpPr>
+        <p:spPr>
+          <a:xfrm>
+            <a:off x="5605054" y="2455978"/>
+            <a:ext cx="2284729" cy="930097"/>
+          </a:xfrm>
+          <a:prstGeom prst="rect">
+            <a:avLst/>
+          </a:prstGeom>
+        </p:spPr>
+        <p:style>
+          <a:lnRef idx="2">
+            <a:schemeClr val="accent1">
+              <a:shade val="15000"/>
+            </a:schemeClr>
+          </a:lnRef>
+          <a:fillRef idx="1">
+            <a:schemeClr val="accent1"/>
+          </a:fillRef>
+          <a:effectRef idx="0">
+            <a:schemeClr val="accent1"/>
+          </a:effectRef>
+          <a:fontRef idx="minor">
+            <a:schemeClr val="lt1"/>
+          </a:fontRef>
+        </p:style>
+        <p:txBody>
+          <a:bodyPr rtlCol="0" anchor="ctr"/>
+          <a:lstStyle/>
+          <a:p>
+            <a:pPr algn="ctr"/>
+            <a:r>
+              <a:rPr lang="en-US" dirty="0"/>
+              <a:t>Fuzzy String Match</a:t>
+            </a:r>
+          </a:p>
+        </p:txBody>
+      </p:sp>
+      <p:pic>
+        <p:nvPicPr>
+          <p:cNvPr id="13" name="Graphic 12" descr="Database outline">
+            <a:extLst>
+              <a:ext uri="{FF2B5EF4-FFF2-40B4-BE49-F238E27FC236}">
+                <a16:creationId xmlns:a16="http://schemas.microsoft.com/office/drawing/2014/main" id="{CA8A991E-041C-F9B3-E255-517A56F31760}"/>
+              </a:ext>
+            </a:extLst>
+          </p:cNvPr>
+          <p:cNvPicPr>
+            <a:picLocks noChangeAspect="1"/>
+          </p:cNvPicPr>
+          <p:nvPr/>
+        </p:nvPicPr>
+        <p:blipFill>
+          <a:blip r:embed="rId5">
+            <a:extLst>
+              <a:ext uri="{96DAC541-7B7A-43D3-8B79-37D633B846F1}">
+                <asvg:svgBlip xmlns:asvg="http://schemas.microsoft.com/office/drawing/2016/SVG/main" r:embed="rId6"/>
+              </a:ext>
+            </a:extLst>
+          </a:blip>
+          <a:stretch>
+            <a:fillRect/>
+          </a:stretch>
+        </p:blipFill>
+        <p:spPr>
+          <a:xfrm>
+            <a:off x="6223666" y="3972217"/>
+            <a:ext cx="1244416" cy="1244416"/>
+          </a:xfrm>
+          <a:prstGeom prst="rect">
+            <a:avLst/>
+          </a:prstGeom>
+        </p:spPr>
+      </p:pic>
+      <p:pic>
+        <p:nvPicPr>
+          <p:cNvPr id="14" name="Graphic 13" descr="Database outline">
+            <a:extLst>
+              <a:ext uri="{FF2B5EF4-FFF2-40B4-BE49-F238E27FC236}">
+                <a16:creationId xmlns:a16="http://schemas.microsoft.com/office/drawing/2014/main" id="{301F0597-96AD-7EFF-38C3-B4AFFAB602E6}"/>
+              </a:ext>
+            </a:extLst>
+          </p:cNvPr>
+          <p:cNvPicPr>
+            <a:picLocks noChangeAspect="1"/>
+          </p:cNvPicPr>
+          <p:nvPr/>
+        </p:nvPicPr>
+        <p:blipFill>
+          <a:blip r:embed="rId5">
+            <a:extLst>
+              <a:ext uri="{96DAC541-7B7A-43D3-8B79-37D633B846F1}">
+                <asvg:svgBlip xmlns:asvg="http://schemas.microsoft.com/office/drawing/2016/SVG/main" r:embed="rId6"/>
+              </a:ext>
+            </a:extLst>
+          </a:blip>
+          <a:stretch>
+            <a:fillRect/>
+          </a:stretch>
+        </p:blipFill>
+        <p:spPr>
+          <a:xfrm>
+            <a:off x="6125211" y="862584"/>
+            <a:ext cx="1244416" cy="1244416"/>
+          </a:xfrm>
+          <a:prstGeom prst="rect">
+            <a:avLst/>
+          </a:prstGeom>
+        </p:spPr>
+      </p:pic>
+      <p:sp>
+        <p:nvSpPr>
+          <p:cNvPr id="16" name="TextBox 15">
+            <a:extLst>
+              <a:ext uri="{FF2B5EF4-FFF2-40B4-BE49-F238E27FC236}">
+                <a16:creationId xmlns:a16="http://schemas.microsoft.com/office/drawing/2014/main" id="{0DB0385E-F451-CD90-1DAF-EBD6E13D3162}"/>
+              </a:ext>
+            </a:extLst>
+          </p:cNvPr>
+          <p:cNvSpPr txBox="1"/>
+          <p:nvPr/>
+        </p:nvSpPr>
+        <p:spPr>
+          <a:xfrm>
+            <a:off x="5258608" y="5094863"/>
+            <a:ext cx="4034478" cy="369332"/>
+          </a:xfrm>
+          <a:prstGeom prst="rect">
+            <a:avLst/>
+          </a:prstGeom>
+          <a:noFill/>
+        </p:spPr>
+        <p:txBody>
+          <a:bodyPr wrap="square" rtlCol="0">
+            <a:spAutoFit/>
+          </a:bodyPr>
+          <a:lstStyle/>
+          <a:p>
+            <a:r>
+              <a:rPr lang="en-US" dirty="0">
+                <a:solidFill>
+                  <a:schemeClr val="bg2">
+                    <a:lumMod val="50000"/>
+                  </a:schemeClr>
+                </a:solidFill>
+              </a:rPr>
+              <a:t>WHO Tumor Classification System</a:t>
+            </a:r>
+          </a:p>
+        </p:txBody>
+      </p:sp>
+      <p:sp>
+        <p:nvSpPr>
+          <p:cNvPr id="17" name="TextBox 16">
+            <a:extLst>
+              <a:ext uri="{FF2B5EF4-FFF2-40B4-BE49-F238E27FC236}">
+                <a16:creationId xmlns:a16="http://schemas.microsoft.com/office/drawing/2014/main" id="{A8E0CCAA-3593-6500-6D5D-A0A1FB7B2BCD}"/>
+              </a:ext>
+            </a:extLst>
+          </p:cNvPr>
+          <p:cNvSpPr txBox="1"/>
+          <p:nvPr/>
+        </p:nvSpPr>
+        <p:spPr>
+          <a:xfrm>
+            <a:off x="5830121" y="616009"/>
+            <a:ext cx="2031506" cy="369332"/>
+          </a:xfrm>
+          <a:prstGeom prst="rect">
+            <a:avLst/>
+          </a:prstGeom>
+          <a:noFill/>
+        </p:spPr>
+        <p:txBody>
+          <a:bodyPr wrap="square" rtlCol="0">
+            <a:spAutoFit/>
+          </a:bodyPr>
+          <a:lstStyle/>
+          <a:p>
+            <a:r>
+              <a:rPr lang="en-US" dirty="0">
+                <a:solidFill>
+                  <a:schemeClr val="bg2">
+                    <a:lumMod val="50000"/>
+                  </a:schemeClr>
+                </a:solidFill>
+              </a:rPr>
+              <a:t>Tumor key words</a:t>
+            </a:r>
+          </a:p>
+        </p:txBody>
+      </p:sp>
+      <p:sp>
+        <p:nvSpPr>
+          <p:cNvPr id="18" name="Right Arrow 17">
+            <a:extLst>
+              <a:ext uri="{FF2B5EF4-FFF2-40B4-BE49-F238E27FC236}">
+                <a16:creationId xmlns:a16="http://schemas.microsoft.com/office/drawing/2014/main" id="{2B39A889-FCA5-B400-E8D3-B49F754BEE2E}"/>
+              </a:ext>
+            </a:extLst>
+          </p:cNvPr>
+          <p:cNvSpPr/>
+          <p:nvPr/>
+        </p:nvSpPr>
+        <p:spPr>
+          <a:xfrm>
+            <a:off x="4385513" y="2616592"/>
+            <a:ext cx="1025495" cy="529839"/>
+          </a:xfrm>
+          <a:prstGeom prst="rightArrow">
+            <a:avLst/>
+          </a:prstGeom>
+        </p:spPr>
+        <p:style>
+          <a:lnRef idx="2">
+            <a:schemeClr val="accent1">
+              <a:shade val="15000"/>
+            </a:schemeClr>
+          </a:lnRef>
+          <a:fillRef idx="1">
+            <a:schemeClr val="accent1"/>
+          </a:fillRef>
+          <a:effectRef idx="0">
+            <a:schemeClr val="accent1"/>
+          </a:effectRef>
+          <a:fontRef idx="minor">
+            <a:schemeClr val="lt1"/>
+          </a:fontRef>
+        </p:style>
+        <p:txBody>
+          <a:bodyPr rtlCol="0" anchor="ctr"/>
+          <a:lstStyle/>
+          <a:p>
+            <a:pPr algn="ctr"/>
+            <a:endParaRPr lang="en-US"/>
+          </a:p>
+        </p:txBody>
+      </p:sp>
+      <p:sp>
+        <p:nvSpPr>
+          <p:cNvPr id="19" name="Down Arrow 18">
+            <a:extLst>
+              <a:ext uri="{FF2B5EF4-FFF2-40B4-BE49-F238E27FC236}">
+                <a16:creationId xmlns:a16="http://schemas.microsoft.com/office/drawing/2014/main" id="{9B216ECB-C5A2-8803-328E-44CE7D138A72}"/>
+              </a:ext>
+            </a:extLst>
+          </p:cNvPr>
+          <p:cNvSpPr/>
+          <p:nvPr/>
+        </p:nvSpPr>
+        <p:spPr>
+          <a:xfrm>
+            <a:off x="6595019" y="2023084"/>
+            <a:ext cx="304800" cy="369333"/>
+          </a:xfrm>
+          <a:prstGeom prst="downArrow">
+            <a:avLst/>
+          </a:prstGeom>
+        </p:spPr>
+        <p:style>
+          <a:lnRef idx="2">
+            <a:schemeClr val="accent1">
+              <a:shade val="15000"/>
+            </a:schemeClr>
+          </a:lnRef>
+          <a:fillRef idx="1">
+            <a:schemeClr val="accent1"/>
+          </a:fillRef>
+          <a:effectRef idx="0">
+            <a:schemeClr val="accent1"/>
+          </a:effectRef>
+          <a:fontRef idx="minor">
+            <a:schemeClr val="lt1"/>
+          </a:fontRef>
+        </p:style>
+        <p:txBody>
+          <a:bodyPr rtlCol="0" anchor="ctr"/>
+          <a:lstStyle/>
+          <a:p>
+            <a:pPr algn="ctr"/>
+            <a:endParaRPr lang="en-US"/>
+          </a:p>
+        </p:txBody>
+      </p:sp>
+      <p:sp>
+        <p:nvSpPr>
+          <p:cNvPr id="20" name="Up Arrow 19">
+            <a:extLst>
+              <a:ext uri="{FF2B5EF4-FFF2-40B4-BE49-F238E27FC236}">
+                <a16:creationId xmlns:a16="http://schemas.microsoft.com/office/drawing/2014/main" id="{73310A80-86DB-204B-8D96-19402D444123}"/>
+              </a:ext>
+            </a:extLst>
+          </p:cNvPr>
+          <p:cNvSpPr/>
+          <p:nvPr/>
+        </p:nvSpPr>
+        <p:spPr>
+          <a:xfrm>
+            <a:off x="6589500" y="3443485"/>
+            <a:ext cx="512747" cy="562340"/>
+          </a:xfrm>
+          <a:prstGeom prst="upArrow">
+            <a:avLst/>
+          </a:prstGeom>
+        </p:spPr>
+        <p:style>
+          <a:lnRef idx="2">
+            <a:schemeClr val="accent1">
+              <a:shade val="15000"/>
+            </a:schemeClr>
+          </a:lnRef>
+          <a:fillRef idx="1">
+            <a:schemeClr val="accent1"/>
+          </a:fillRef>
+          <a:effectRef idx="0">
+            <a:schemeClr val="accent1"/>
+          </a:effectRef>
+          <a:fontRef idx="minor">
+            <a:schemeClr val="lt1"/>
+          </a:fontRef>
+        </p:style>
+        <p:txBody>
+          <a:bodyPr rtlCol="0" anchor="ctr"/>
+          <a:lstStyle/>
+          <a:p>
+            <a:pPr algn="ctr"/>
+            <a:endParaRPr lang="en-US"/>
+          </a:p>
+        </p:txBody>
+      </p:sp>
+      <p:sp>
+        <p:nvSpPr>
+          <p:cNvPr id="21" name="Rectangle 20">
+            <a:extLst>
+              <a:ext uri="{FF2B5EF4-FFF2-40B4-BE49-F238E27FC236}">
+                <a16:creationId xmlns:a16="http://schemas.microsoft.com/office/drawing/2014/main" id="{D44FC835-E36F-AA70-EB8A-A508E553CA79}"/>
+              </a:ext>
+            </a:extLst>
+          </p:cNvPr>
+          <p:cNvSpPr/>
+          <p:nvPr/>
+        </p:nvSpPr>
+        <p:spPr>
+          <a:xfrm>
+            <a:off x="9158480" y="2383892"/>
+            <a:ext cx="2284729" cy="930097"/>
+          </a:xfrm>
+          <a:prstGeom prst="rect">
+            <a:avLst/>
+          </a:prstGeom>
+        </p:spPr>
+        <p:style>
+          <a:lnRef idx="2">
+            <a:schemeClr val="accent1">
+              <a:shade val="15000"/>
+            </a:schemeClr>
+          </a:lnRef>
+          <a:fillRef idx="1">
+            <a:schemeClr val="accent1"/>
+          </a:fillRef>
+          <a:effectRef idx="0">
+            <a:schemeClr val="accent1"/>
+          </a:effectRef>
+          <a:fontRef idx="minor">
+            <a:schemeClr val="lt1"/>
+          </a:fontRef>
+        </p:style>
+        <p:txBody>
+          <a:bodyPr rtlCol="0" anchor="ctr"/>
+          <a:lstStyle/>
+          <a:p>
+            <a:pPr algn="ctr"/>
+            <a:r>
+              <a:rPr lang="en-US" dirty="0"/>
+              <a:t>Flag tumor and manually validate</a:t>
+            </a:r>
+          </a:p>
+        </p:txBody>
+      </p:sp>
+      <p:sp>
+        <p:nvSpPr>
+          <p:cNvPr id="22" name="Right Arrow 21">
+            <a:extLst>
+              <a:ext uri="{FF2B5EF4-FFF2-40B4-BE49-F238E27FC236}">
+                <a16:creationId xmlns:a16="http://schemas.microsoft.com/office/drawing/2014/main" id="{3F4E4C5A-9D0E-A829-80F2-9E0BA92A71AB}"/>
+              </a:ext>
+            </a:extLst>
+          </p:cNvPr>
+          <p:cNvSpPr/>
+          <p:nvPr/>
+        </p:nvSpPr>
+        <p:spPr>
+          <a:xfrm>
+            <a:off x="7996271" y="2616591"/>
+            <a:ext cx="1025495" cy="529839"/>
+          </a:xfrm>
+          <a:prstGeom prst="rightArrow">
+            <a:avLst/>
+          </a:prstGeom>
+        </p:spPr>
+        <p:style>
+          <a:lnRef idx="2">
+            <a:schemeClr val="accent1">
+              <a:shade val="15000"/>
+            </a:schemeClr>
+          </a:lnRef>
+          <a:fillRef idx="1">
+            <a:schemeClr val="accent1"/>
+          </a:fillRef>
+          <a:effectRef idx="0">
+            <a:schemeClr val="accent1"/>
+          </a:effectRef>
+          <a:fontRef idx="minor">
+            <a:schemeClr val="lt1"/>
+          </a:fontRef>
+        </p:style>
+        <p:txBody>
+          <a:bodyPr rtlCol="0" anchor="ctr"/>
+          <a:lstStyle/>
+          <a:p>
+            <a:pPr algn="ctr"/>
             <a:endParaRPr lang="en-US"/>
           </a:p>
         </p:txBody>

</xml_diff>

<commit_message>
update cantos with models
</commit_message>
<xml_diff>
--- a/presentations/CANTOS_PPT.pptx
+++ b/presentations/CANTOS_PPT.pptx
@@ -5,7 +5,7 @@
     <p:sldMasterId id="2147483672" r:id="rId4"/>
   </p:sldMasterIdLst>
   <p:notesMasterIdLst>
-    <p:notesMasterId r:id="rId14"/>
+    <p:notesMasterId r:id="rId19"/>
   </p:notesMasterIdLst>
   <p:sldIdLst>
     <p:sldId id="256" r:id="rId5"/>
@@ -17,6 +17,11 @@
     <p:sldId id="259" r:id="rId11"/>
     <p:sldId id="264" r:id="rId12"/>
     <p:sldId id="258" r:id="rId13"/>
+    <p:sldId id="267" r:id="rId14"/>
+    <p:sldId id="265" r:id="rId15"/>
+    <p:sldId id="268" r:id="rId16"/>
+    <p:sldId id="266" r:id="rId17"/>
+    <p:sldId id="269" r:id="rId18"/>
   </p:sldIdLst>
   <p:sldSz cx="12192000" cy="6858000"/>
   <p:notesSz cx="6858000" cy="9144000"/>
@@ -1687,6 +1692,2456 @@
     <p:extLst>
       <p:ext uri="{BB962C8B-B14F-4D97-AF65-F5344CB8AC3E}">
         <p14:creationId xmlns:p14="http://schemas.microsoft.com/office/powerpoint/2010/main" val="682876590"/>
+      </p:ext>
+    </p:extLst>
+  </p:cSld>
+  <p:clrMapOvr>
+    <a:masterClrMapping/>
+  </p:clrMapOvr>
+</p:sld>
+</file>
+
+<file path=ppt/slides/slide10.xml><?xml version="1.0" encoding="utf-8"?>
+<p:sld xmlns:a="http://schemas.openxmlformats.org/drawingml/2006/main" xmlns:r="http://schemas.openxmlformats.org/officeDocument/2006/relationships" xmlns:p="http://schemas.openxmlformats.org/presentationml/2006/main">
+  <p:cSld>
+    <p:spTree>
+      <p:nvGrpSpPr>
+        <p:cNvPr id="1" name="">
+          <a:extLst>
+            <a:ext uri="{FF2B5EF4-FFF2-40B4-BE49-F238E27FC236}">
+              <a16:creationId xmlns:a16="http://schemas.microsoft.com/office/drawing/2014/main" id="{E9CE722E-3FCD-FD45-A0E6-12A95F208F4A}"/>
+            </a:ext>
+          </a:extLst>
+        </p:cNvPr>
+        <p:cNvGrpSpPr/>
+        <p:nvPr/>
+      </p:nvGrpSpPr>
+      <p:grpSpPr>
+        <a:xfrm>
+          <a:off x="0" y="0"/>
+          <a:ext cx="0" cy="0"/>
+          <a:chOff x="0" y="0"/>
+          <a:chExt cx="0" cy="0"/>
+        </a:xfrm>
+      </p:grpSpPr>
+      <p:sp>
+        <p:nvSpPr>
+          <p:cNvPr id="2" name="Title 1">
+            <a:extLst>
+              <a:ext uri="{FF2B5EF4-FFF2-40B4-BE49-F238E27FC236}">
+                <a16:creationId xmlns:a16="http://schemas.microsoft.com/office/drawing/2014/main" id="{C95D30D7-FC81-7A2E-2D28-63AA04393E7F}"/>
+              </a:ext>
+            </a:extLst>
+          </p:cNvPr>
+          <p:cNvSpPr>
+            <a:spLocks noGrp="1"/>
+          </p:cNvSpPr>
+          <p:nvPr>
+            <p:ph type="title"/>
+          </p:nvPr>
+        </p:nvSpPr>
+        <p:spPr>
+          <a:xfrm>
+            <a:off x="87086" y="21771"/>
+            <a:ext cx="10651402" cy="1143000"/>
+          </a:xfrm>
+        </p:spPr>
+        <p:txBody>
+          <a:bodyPr/>
+          <a:lstStyle/>
+          <a:p>
+            <a:r>
+              <a:rPr lang="en-US" dirty="0"/>
+              <a:t>Tumor Name Standardization		</a:t>
+            </a:r>
+          </a:p>
+        </p:txBody>
+      </p:sp>
+      <p:sp>
+        <p:nvSpPr>
+          <p:cNvPr id="3" name="Content Placeholder 2">
+            <a:extLst>
+              <a:ext uri="{FF2B5EF4-FFF2-40B4-BE49-F238E27FC236}">
+                <a16:creationId xmlns:a16="http://schemas.microsoft.com/office/drawing/2014/main" id="{03E5FCE7-F75E-2327-9C5F-55E00B34D11D}"/>
+              </a:ext>
+            </a:extLst>
+          </p:cNvPr>
+          <p:cNvSpPr>
+            <a:spLocks noGrp="1"/>
+          </p:cNvSpPr>
+          <p:nvPr>
+            <p:ph idx="1"/>
+          </p:nvPr>
+        </p:nvSpPr>
+        <p:spPr>
+          <a:xfrm>
+            <a:off x="179670" y="1164771"/>
+            <a:ext cx="11261215" cy="4484914"/>
+          </a:xfrm>
+        </p:spPr>
+        <p:txBody>
+          <a:bodyPr>
+            <a:normAutofit/>
+          </a:bodyPr>
+          <a:lstStyle/>
+          <a:p>
+            <a:pPr algn="just"/>
+            <a:r>
+              <a:rPr lang="en-US" sz="1800" dirty="0">
+                <a:solidFill>
+                  <a:schemeClr val="tx1"/>
+                </a:solidFill>
+                <a:latin typeface="+mn-lt"/>
+                <a:cs typeface="+mn-cs"/>
+              </a:rPr>
+              <a:t>Edit distances: are a way of measuring how different two strings (sequences of characters) are. The edit distance is the minimum number of operations needed to transform one string into another. E.g. </a:t>
+            </a:r>
+            <a:r>
+              <a:rPr lang="en-US" sz="1800" dirty="0" err="1">
+                <a:solidFill>
+                  <a:schemeClr val="tx1"/>
+                </a:solidFill>
+                <a:latin typeface="+mn-lt"/>
+                <a:cs typeface="+mn-cs"/>
+              </a:rPr>
+              <a:t>Levenshtein</a:t>
+            </a:r>
+            <a:r>
+              <a:rPr lang="en-US" sz="1800" dirty="0">
+                <a:solidFill>
+                  <a:schemeClr val="tx1"/>
+                </a:solidFill>
+                <a:latin typeface="+mn-lt"/>
+                <a:cs typeface="+mn-cs"/>
+              </a:rPr>
+              <a:t> , cosine, </a:t>
+            </a:r>
+            <a:r>
+              <a:rPr lang="en-US" sz="1800" dirty="0" err="1">
+                <a:solidFill>
+                  <a:schemeClr val="tx1"/>
+                </a:solidFill>
+                <a:latin typeface="+mn-lt"/>
+                <a:cs typeface="+mn-cs"/>
+              </a:rPr>
+              <a:t>jarro-winkler</a:t>
+            </a:r>
+            <a:r>
+              <a:rPr lang="en-US" sz="1800" dirty="0">
+                <a:solidFill>
+                  <a:schemeClr val="tx1"/>
+                </a:solidFill>
+                <a:latin typeface="+mn-lt"/>
+                <a:cs typeface="+mn-cs"/>
+              </a:rPr>
+              <a:t> etc. </a:t>
+            </a:r>
+          </a:p>
+          <a:p>
+            <a:pPr algn="just"/>
+            <a:endParaRPr lang="en-US" sz="1800" dirty="0">
+              <a:solidFill>
+                <a:schemeClr val="tx1"/>
+              </a:solidFill>
+              <a:latin typeface="+mn-lt"/>
+              <a:cs typeface="+mn-cs"/>
+            </a:endParaRPr>
+          </a:p>
+          <a:p>
+            <a:endParaRPr lang="en-US" sz="1800" dirty="0">
+              <a:solidFill>
+                <a:srgbClr val="000000"/>
+              </a:solidFill>
+              <a:latin typeface="Times New Roman" panose="02020603050405020304" pitchFamily="18" charset="0"/>
+            </a:endParaRPr>
+          </a:p>
+          <a:p>
+            <a:endParaRPr lang="en-US" sz="1800" dirty="0">
+              <a:solidFill>
+                <a:srgbClr val="000000"/>
+              </a:solidFill>
+              <a:latin typeface="Times New Roman" panose="02020603050405020304" pitchFamily="18" charset="0"/>
+            </a:endParaRPr>
+          </a:p>
+          <a:p>
+            <a:endParaRPr lang="en-US" dirty="0"/>
+          </a:p>
+        </p:txBody>
+      </p:sp>
+      <p:sp>
+        <p:nvSpPr>
+          <p:cNvPr id="4" name="Slide Number Placeholder 3">
+            <a:extLst>
+              <a:ext uri="{FF2B5EF4-FFF2-40B4-BE49-F238E27FC236}">
+                <a16:creationId xmlns:a16="http://schemas.microsoft.com/office/drawing/2014/main" id="{79537068-5C1D-29E8-6A44-3E3880B225DF}"/>
+              </a:ext>
+            </a:extLst>
+          </p:cNvPr>
+          <p:cNvSpPr>
+            <a:spLocks noGrp="1"/>
+          </p:cNvSpPr>
+          <p:nvPr>
+            <p:ph type="sldNum" sz="quarter" idx="12"/>
+          </p:nvPr>
+        </p:nvSpPr>
+        <p:spPr/>
+        <p:txBody>
+          <a:bodyPr/>
+          <a:lstStyle/>
+          <a:p>
+            <a:fld id="{AD40181A-01B0-4CB8-8614-1473649F6741}" type="slidenum">
+              <a:rPr lang="en-US" smtClean="0">
+                <a:solidFill>
+                  <a:schemeClr val="bg1"/>
+                </a:solidFill>
+              </a:rPr>
+              <a:t>10</a:t>
+            </a:fld>
+            <a:endParaRPr lang="en-US" dirty="0">
+              <a:solidFill>
+                <a:schemeClr val="bg1"/>
+              </a:solidFill>
+            </a:endParaRPr>
+          </a:p>
+        </p:txBody>
+      </p:sp>
+    </p:spTree>
+    <p:extLst>
+      <p:ext uri="{BB962C8B-B14F-4D97-AF65-F5344CB8AC3E}">
+        <p14:creationId xmlns:p14="http://schemas.microsoft.com/office/powerpoint/2010/main" val="2648807902"/>
+      </p:ext>
+    </p:extLst>
+  </p:cSld>
+  <p:clrMapOvr>
+    <a:masterClrMapping/>
+  </p:clrMapOvr>
+</p:sld>
+</file>
+
+<file path=ppt/slides/slide11.xml><?xml version="1.0" encoding="utf-8"?>
+<p:sld xmlns:a="http://schemas.openxmlformats.org/drawingml/2006/main" xmlns:r="http://schemas.openxmlformats.org/officeDocument/2006/relationships" xmlns:p="http://schemas.openxmlformats.org/presentationml/2006/main">
+  <p:cSld>
+    <p:spTree>
+      <p:nvGrpSpPr>
+        <p:cNvPr id="1" name="">
+          <a:extLst>
+            <a:ext uri="{FF2B5EF4-FFF2-40B4-BE49-F238E27FC236}">
+              <a16:creationId xmlns:a16="http://schemas.microsoft.com/office/drawing/2014/main" id="{109860D5-0ADE-5792-F38B-E62C062F6D1C}"/>
+            </a:ext>
+          </a:extLst>
+        </p:cNvPr>
+        <p:cNvGrpSpPr/>
+        <p:nvPr/>
+      </p:nvGrpSpPr>
+      <p:grpSpPr>
+        <a:xfrm>
+          <a:off x="0" y="0"/>
+          <a:ext cx="0" cy="0"/>
+          <a:chOff x="0" y="0"/>
+          <a:chExt cx="0" cy="0"/>
+        </a:xfrm>
+      </p:grpSpPr>
+      <p:sp>
+        <p:nvSpPr>
+          <p:cNvPr id="2" name="Slide Number Placeholder 1">
+            <a:extLst>
+              <a:ext uri="{FF2B5EF4-FFF2-40B4-BE49-F238E27FC236}">
+                <a16:creationId xmlns:a16="http://schemas.microsoft.com/office/drawing/2014/main" id="{8ACD26A8-2FC8-DD30-97D2-0E40EAF5ADBF}"/>
+              </a:ext>
+            </a:extLst>
+          </p:cNvPr>
+          <p:cNvSpPr>
+            <a:spLocks noGrp="1"/>
+          </p:cNvSpPr>
+          <p:nvPr>
+            <p:ph type="sldNum" sz="quarter" idx="12"/>
+          </p:nvPr>
+        </p:nvSpPr>
+        <p:spPr/>
+        <p:txBody>
+          <a:bodyPr/>
+          <a:lstStyle/>
+          <a:p>
+            <a:fld id="{AD40181A-01B0-4CB8-8614-1473649F6741}" type="slidenum">
+              <a:rPr lang="en-US" smtClean="0">
+                <a:solidFill>
+                  <a:srgbClr val="FFFFFE"/>
+                </a:solidFill>
+              </a:rPr>
+              <a:t>11</a:t>
+            </a:fld>
+            <a:endParaRPr lang="en-US" dirty="0">
+              <a:solidFill>
+                <a:srgbClr val="FFFFFE"/>
+              </a:solidFill>
+            </a:endParaRPr>
+          </a:p>
+        </p:txBody>
+      </p:sp>
+      <p:sp>
+        <p:nvSpPr>
+          <p:cNvPr id="3" name="Title 2">
+            <a:extLst>
+              <a:ext uri="{FF2B5EF4-FFF2-40B4-BE49-F238E27FC236}">
+                <a16:creationId xmlns:a16="http://schemas.microsoft.com/office/drawing/2014/main" id="{B1C6C862-386D-12B2-A6B7-8D9654E3FF35}"/>
+              </a:ext>
+            </a:extLst>
+          </p:cNvPr>
+          <p:cNvSpPr>
+            <a:spLocks noGrp="1"/>
+          </p:cNvSpPr>
+          <p:nvPr>
+            <p:ph type="title"/>
+          </p:nvPr>
+        </p:nvSpPr>
+        <p:spPr>
+          <a:xfrm>
+            <a:off x="0" y="-294409"/>
+            <a:ext cx="11874374" cy="1279750"/>
+          </a:xfrm>
+        </p:spPr>
+        <p:txBody>
+          <a:bodyPr/>
+          <a:lstStyle/>
+          <a:p>
+            <a:r>
+              <a:rPr lang="en-US" dirty="0"/>
+              <a:t>CANTOS : Tumor Name Standardization phase</a:t>
+            </a:r>
+          </a:p>
+        </p:txBody>
+      </p:sp>
+      <p:pic>
+        <p:nvPicPr>
+          <p:cNvPr id="5" name="Graphic 4" descr="Document outline">
+            <a:extLst>
+              <a:ext uri="{FF2B5EF4-FFF2-40B4-BE49-F238E27FC236}">
+                <a16:creationId xmlns:a16="http://schemas.microsoft.com/office/drawing/2014/main" id="{42B33DF4-60C2-1A56-0331-095B57C41900}"/>
+              </a:ext>
+            </a:extLst>
+          </p:cNvPr>
+          <p:cNvPicPr>
+            <a:picLocks noChangeAspect="1"/>
+          </p:cNvPicPr>
+          <p:nvPr/>
+        </p:nvPicPr>
+        <p:blipFill>
+          <a:blip r:embed="rId2">
+            <a:extLst>
+              <a:ext uri="{96DAC541-7B7A-43D3-8B79-37D633B846F1}">
+                <asvg:svgBlip xmlns:asvg="http://schemas.microsoft.com/office/drawing/2016/SVG/main" r:embed="rId3"/>
+              </a:ext>
+            </a:extLst>
+          </a:blip>
+          <a:stretch>
+            <a:fillRect/>
+          </a:stretch>
+        </p:blipFill>
+        <p:spPr>
+          <a:xfrm>
+            <a:off x="85015" y="716462"/>
+            <a:ext cx="1122081" cy="1122081"/>
+          </a:xfrm>
+          <a:prstGeom prst="rect">
+            <a:avLst/>
+          </a:prstGeom>
+        </p:spPr>
+      </p:pic>
+      <p:sp>
+        <p:nvSpPr>
+          <p:cNvPr id="6" name="TextBox 5">
+            <a:extLst>
+              <a:ext uri="{FF2B5EF4-FFF2-40B4-BE49-F238E27FC236}">
+                <a16:creationId xmlns:a16="http://schemas.microsoft.com/office/drawing/2014/main" id="{E776795F-7ACE-3F42-6A31-D87C253DD4B3}"/>
+              </a:ext>
+            </a:extLst>
+          </p:cNvPr>
+          <p:cNvSpPr txBox="1"/>
+          <p:nvPr/>
+        </p:nvSpPr>
+        <p:spPr>
+          <a:xfrm>
+            <a:off x="26800" y="1834241"/>
+            <a:ext cx="1877437" cy="646331"/>
+          </a:xfrm>
+          <a:prstGeom prst="rect">
+            <a:avLst/>
+          </a:prstGeom>
+          <a:noFill/>
+        </p:spPr>
+        <p:txBody>
+          <a:bodyPr wrap="none" rtlCol="0">
+            <a:spAutoFit/>
+          </a:bodyPr>
+          <a:lstStyle/>
+          <a:p>
+            <a:r>
+              <a:rPr lang="en-US" dirty="0">
+                <a:solidFill>
+                  <a:schemeClr val="bg2">
+                    <a:lumMod val="50000"/>
+                  </a:schemeClr>
+                </a:solidFill>
+              </a:rPr>
+              <a:t>Unstandardized </a:t>
+            </a:r>
+            <a:br>
+              <a:rPr lang="en-US" dirty="0">
+                <a:solidFill>
+                  <a:schemeClr val="bg2">
+                    <a:lumMod val="50000"/>
+                  </a:schemeClr>
+                </a:solidFill>
+              </a:rPr>
+            </a:br>
+            <a:r>
+              <a:rPr lang="en-US" dirty="0">
+                <a:solidFill>
+                  <a:schemeClr val="bg2">
+                    <a:lumMod val="50000"/>
+                  </a:schemeClr>
+                </a:solidFill>
+              </a:rPr>
+              <a:t>Tumor </a:t>
+            </a:r>
+            <a:r>
+              <a:rPr lang="en-US" dirty="0" err="1">
+                <a:solidFill>
+                  <a:schemeClr val="bg2">
+                    <a:lumMod val="50000"/>
+                  </a:schemeClr>
+                </a:solidFill>
+              </a:rPr>
+              <a:t>List.csv</a:t>
+            </a:r>
+            <a:endParaRPr lang="en-US" dirty="0">
+              <a:solidFill>
+                <a:schemeClr val="bg2">
+                  <a:lumMod val="50000"/>
+                </a:schemeClr>
+              </a:solidFill>
+            </a:endParaRPr>
+          </a:p>
+        </p:txBody>
+      </p:sp>
+      <p:pic>
+        <p:nvPicPr>
+          <p:cNvPr id="9" name="Graphic 8" descr="Database outline">
+            <a:extLst>
+              <a:ext uri="{FF2B5EF4-FFF2-40B4-BE49-F238E27FC236}">
+                <a16:creationId xmlns:a16="http://schemas.microsoft.com/office/drawing/2014/main" id="{9D1933F5-1AFB-BFD9-ED47-ABC750D7470C}"/>
+              </a:ext>
+            </a:extLst>
+          </p:cNvPr>
+          <p:cNvPicPr>
+            <a:picLocks noChangeAspect="1"/>
+          </p:cNvPicPr>
+          <p:nvPr/>
+        </p:nvPicPr>
+        <p:blipFill>
+          <a:blip r:embed="rId4">
+            <a:extLst>
+              <a:ext uri="{96DAC541-7B7A-43D3-8B79-37D633B846F1}">
+                <asvg:svgBlip xmlns:asvg="http://schemas.microsoft.com/office/drawing/2016/SVG/main" r:embed="rId5"/>
+              </a:ext>
+            </a:extLst>
+          </a:blip>
+          <a:stretch>
+            <a:fillRect/>
+          </a:stretch>
+        </p:blipFill>
+        <p:spPr>
+          <a:xfrm>
+            <a:off x="191306" y="2471051"/>
+            <a:ext cx="1244416" cy="1244416"/>
+          </a:xfrm>
+          <a:prstGeom prst="rect">
+            <a:avLst/>
+          </a:prstGeom>
+        </p:spPr>
+      </p:pic>
+      <p:sp>
+        <p:nvSpPr>
+          <p:cNvPr id="10" name="TextBox 9">
+            <a:extLst>
+              <a:ext uri="{FF2B5EF4-FFF2-40B4-BE49-F238E27FC236}">
+                <a16:creationId xmlns:a16="http://schemas.microsoft.com/office/drawing/2014/main" id="{F3AF1533-C3BE-BE71-98C1-E47E9B9F2B8C}"/>
+              </a:ext>
+            </a:extLst>
+          </p:cNvPr>
+          <p:cNvSpPr txBox="1"/>
+          <p:nvPr/>
+        </p:nvSpPr>
+        <p:spPr>
+          <a:xfrm>
+            <a:off x="14874" y="3644757"/>
+            <a:ext cx="1765922" cy="923330"/>
+          </a:xfrm>
+          <a:prstGeom prst="rect">
+            <a:avLst/>
+          </a:prstGeom>
+          <a:noFill/>
+        </p:spPr>
+        <p:txBody>
+          <a:bodyPr wrap="square" rtlCol="0">
+            <a:spAutoFit/>
+          </a:bodyPr>
+          <a:lstStyle/>
+          <a:p>
+            <a:pPr algn="ctr"/>
+            <a:r>
+              <a:rPr lang="en-US" dirty="0">
+                <a:solidFill>
+                  <a:schemeClr val="bg2">
+                    <a:lumMod val="50000"/>
+                  </a:schemeClr>
+                </a:solidFill>
+              </a:rPr>
+              <a:t>WHO Tumor Classification System</a:t>
+            </a:r>
+          </a:p>
+        </p:txBody>
+      </p:sp>
+      <p:sp>
+        <p:nvSpPr>
+          <p:cNvPr id="12" name="Rectangle 11">
+            <a:extLst>
+              <a:ext uri="{FF2B5EF4-FFF2-40B4-BE49-F238E27FC236}">
+                <a16:creationId xmlns:a16="http://schemas.microsoft.com/office/drawing/2014/main" id="{2DACE30A-D8C5-7184-1BB4-91D4E0E5CA43}"/>
+              </a:ext>
+            </a:extLst>
+          </p:cNvPr>
+          <p:cNvSpPr/>
+          <p:nvPr/>
+        </p:nvSpPr>
+        <p:spPr>
+          <a:xfrm>
+            <a:off x="2629512" y="1054229"/>
+            <a:ext cx="2907576" cy="837415"/>
+          </a:xfrm>
+          <a:prstGeom prst="rect">
+            <a:avLst/>
+          </a:prstGeom>
+        </p:spPr>
+        <p:style>
+          <a:lnRef idx="2">
+            <a:schemeClr val="accent1">
+              <a:shade val="15000"/>
+            </a:schemeClr>
+          </a:lnRef>
+          <a:fillRef idx="1">
+            <a:schemeClr val="accent1"/>
+          </a:fillRef>
+          <a:effectRef idx="0">
+            <a:schemeClr val="accent1"/>
+          </a:effectRef>
+          <a:fontRef idx="minor">
+            <a:schemeClr val="lt1"/>
+          </a:fontRef>
+        </p:style>
+        <p:txBody>
+          <a:bodyPr rtlCol="0" anchor="ctr"/>
+          <a:lstStyle/>
+          <a:p>
+            <a:pPr algn="ctr"/>
+            <a:r>
+              <a:rPr lang="en-US" dirty="0"/>
+              <a:t>Compute edit distance: Cosine, </a:t>
+            </a:r>
+            <a:r>
+              <a:rPr lang="en-US" dirty="0" err="1"/>
+              <a:t>Jarro</a:t>
+            </a:r>
+            <a:r>
+              <a:rPr lang="en-US" dirty="0"/>
+              <a:t> Winkler, </a:t>
+            </a:r>
+            <a:r>
+              <a:rPr lang="en-US" dirty="0" err="1"/>
+              <a:t>Levenshtein</a:t>
+            </a:r>
+            <a:endParaRPr lang="en-US" dirty="0"/>
+          </a:p>
+        </p:txBody>
+      </p:sp>
+      <p:sp>
+        <p:nvSpPr>
+          <p:cNvPr id="24" name="Right Arrow 23">
+            <a:extLst>
+              <a:ext uri="{FF2B5EF4-FFF2-40B4-BE49-F238E27FC236}">
+                <a16:creationId xmlns:a16="http://schemas.microsoft.com/office/drawing/2014/main" id="{DB2CF8BF-C061-21CA-3A3F-608F28B494D7}"/>
+              </a:ext>
+            </a:extLst>
+          </p:cNvPr>
+          <p:cNvSpPr/>
+          <p:nvPr/>
+        </p:nvSpPr>
+        <p:spPr>
+          <a:xfrm>
+            <a:off x="5747659" y="1136938"/>
+            <a:ext cx="1025495" cy="529839"/>
+          </a:xfrm>
+          <a:prstGeom prst="rightArrow">
+            <a:avLst/>
+          </a:prstGeom>
+        </p:spPr>
+        <p:style>
+          <a:lnRef idx="2">
+            <a:schemeClr val="accent1">
+              <a:shade val="15000"/>
+            </a:schemeClr>
+          </a:lnRef>
+          <a:fillRef idx="1">
+            <a:schemeClr val="accent1"/>
+          </a:fillRef>
+          <a:effectRef idx="0">
+            <a:schemeClr val="accent1"/>
+          </a:effectRef>
+          <a:fontRef idx="minor">
+            <a:schemeClr val="lt1"/>
+          </a:fontRef>
+        </p:style>
+        <p:txBody>
+          <a:bodyPr rtlCol="0" anchor="ctr"/>
+          <a:lstStyle/>
+          <a:p>
+            <a:pPr algn="ctr"/>
+            <a:endParaRPr lang="en-US"/>
+          </a:p>
+        </p:txBody>
+      </p:sp>
+      <p:sp>
+        <p:nvSpPr>
+          <p:cNvPr id="25" name="Rectangle 24">
+            <a:extLst>
+              <a:ext uri="{FF2B5EF4-FFF2-40B4-BE49-F238E27FC236}">
+                <a16:creationId xmlns:a16="http://schemas.microsoft.com/office/drawing/2014/main" id="{B5DF64D4-81B9-73C2-DD97-9F86B72DC86F}"/>
+              </a:ext>
+            </a:extLst>
+          </p:cNvPr>
+          <p:cNvSpPr/>
+          <p:nvPr/>
+        </p:nvSpPr>
+        <p:spPr>
+          <a:xfrm>
+            <a:off x="7030939" y="1001030"/>
+            <a:ext cx="3777046" cy="952919"/>
+          </a:xfrm>
+          <a:prstGeom prst="rect">
+            <a:avLst/>
+          </a:prstGeom>
+          <a:solidFill>
+            <a:schemeClr val="accent3">
+              <a:lumMod val="60000"/>
+              <a:lumOff val="40000"/>
+            </a:schemeClr>
+          </a:solidFill>
+        </p:spPr>
+        <p:style>
+          <a:lnRef idx="2">
+            <a:schemeClr val="accent1">
+              <a:shade val="15000"/>
+            </a:schemeClr>
+          </a:lnRef>
+          <a:fillRef idx="1">
+            <a:schemeClr val="accent1"/>
+          </a:fillRef>
+          <a:effectRef idx="0">
+            <a:schemeClr val="accent1"/>
+          </a:effectRef>
+          <a:fontRef idx="minor">
+            <a:schemeClr val="lt1"/>
+          </a:fontRef>
+        </p:style>
+        <p:txBody>
+          <a:bodyPr rtlCol="0" anchor="ctr"/>
+          <a:lstStyle/>
+          <a:p>
+            <a:pPr algn="ctr"/>
+            <a:r>
+              <a:rPr lang="en-US" dirty="0"/>
+              <a:t>Assign the closest standardized tumor name to the unstandardized tumor name from CTR</a:t>
+            </a:r>
+          </a:p>
+        </p:txBody>
+      </p:sp>
+      <p:sp>
+        <p:nvSpPr>
+          <p:cNvPr id="26" name="Rectangle 25">
+            <a:extLst>
+              <a:ext uri="{FF2B5EF4-FFF2-40B4-BE49-F238E27FC236}">
+                <a16:creationId xmlns:a16="http://schemas.microsoft.com/office/drawing/2014/main" id="{EC4A64BD-7770-C661-5A64-7BF246DDB17A}"/>
+              </a:ext>
+            </a:extLst>
+          </p:cNvPr>
+          <p:cNvSpPr/>
+          <p:nvPr/>
+        </p:nvSpPr>
+        <p:spPr>
+          <a:xfrm>
+            <a:off x="2683316" y="2700388"/>
+            <a:ext cx="3071488" cy="717907"/>
+          </a:xfrm>
+          <a:prstGeom prst="rect">
+            <a:avLst/>
+          </a:prstGeom>
+        </p:spPr>
+        <p:style>
+          <a:lnRef idx="2">
+            <a:schemeClr val="accent1">
+              <a:shade val="15000"/>
+            </a:schemeClr>
+          </a:lnRef>
+          <a:fillRef idx="1">
+            <a:schemeClr val="accent1"/>
+          </a:fillRef>
+          <a:effectRef idx="0">
+            <a:schemeClr val="accent1"/>
+          </a:effectRef>
+          <a:fontRef idx="minor">
+            <a:schemeClr val="lt1"/>
+          </a:fontRef>
+        </p:style>
+        <p:txBody>
+          <a:bodyPr rtlCol="0" anchor="ctr"/>
+          <a:lstStyle/>
+          <a:p>
+            <a:pPr algn="ctr"/>
+            <a:r>
+              <a:rPr lang="en-US" dirty="0"/>
+              <a:t>Use edit distance to cluster: Affinity Propagation</a:t>
+            </a:r>
+          </a:p>
+        </p:txBody>
+      </p:sp>
+      <p:sp>
+        <p:nvSpPr>
+          <p:cNvPr id="27" name="Right Arrow 26">
+            <a:extLst>
+              <a:ext uri="{FF2B5EF4-FFF2-40B4-BE49-F238E27FC236}">
+                <a16:creationId xmlns:a16="http://schemas.microsoft.com/office/drawing/2014/main" id="{B8B5E91A-3F3D-35CB-83A7-23E4CFFCD7FE}"/>
+              </a:ext>
+            </a:extLst>
+          </p:cNvPr>
+          <p:cNvSpPr/>
+          <p:nvPr/>
+        </p:nvSpPr>
+        <p:spPr>
+          <a:xfrm rot="5400000">
+            <a:off x="3820459" y="2017283"/>
+            <a:ext cx="717906" cy="554994"/>
+          </a:xfrm>
+          <a:prstGeom prst="rightArrow">
+            <a:avLst/>
+          </a:prstGeom>
+        </p:spPr>
+        <p:style>
+          <a:lnRef idx="2">
+            <a:schemeClr val="accent1">
+              <a:shade val="15000"/>
+            </a:schemeClr>
+          </a:lnRef>
+          <a:fillRef idx="1">
+            <a:schemeClr val="accent1"/>
+          </a:fillRef>
+          <a:effectRef idx="0">
+            <a:schemeClr val="accent1"/>
+          </a:effectRef>
+          <a:fontRef idx="minor">
+            <a:schemeClr val="lt1"/>
+          </a:fontRef>
+        </p:style>
+        <p:txBody>
+          <a:bodyPr rtlCol="0" anchor="ctr"/>
+          <a:lstStyle/>
+          <a:p>
+            <a:pPr algn="ctr"/>
+            <a:endParaRPr lang="en-US"/>
+          </a:p>
+        </p:txBody>
+      </p:sp>
+      <p:sp>
+        <p:nvSpPr>
+          <p:cNvPr id="28" name="Rectangle 27">
+            <a:extLst>
+              <a:ext uri="{FF2B5EF4-FFF2-40B4-BE49-F238E27FC236}">
+                <a16:creationId xmlns:a16="http://schemas.microsoft.com/office/drawing/2014/main" id="{926E6448-7FF8-7D01-CB23-D9DE6B6960D9}"/>
+              </a:ext>
+            </a:extLst>
+          </p:cNvPr>
+          <p:cNvSpPr/>
+          <p:nvPr/>
+        </p:nvSpPr>
+        <p:spPr>
+          <a:xfrm>
+            <a:off x="2296830" y="4297254"/>
+            <a:ext cx="3765164" cy="860083"/>
+          </a:xfrm>
+          <a:prstGeom prst="rect">
+            <a:avLst/>
+          </a:prstGeom>
+        </p:spPr>
+        <p:style>
+          <a:lnRef idx="2">
+            <a:schemeClr val="accent1">
+              <a:shade val="15000"/>
+            </a:schemeClr>
+          </a:lnRef>
+          <a:fillRef idx="1">
+            <a:schemeClr val="accent1"/>
+          </a:fillRef>
+          <a:effectRef idx="0">
+            <a:schemeClr val="accent1"/>
+          </a:effectRef>
+          <a:fontRef idx="minor">
+            <a:schemeClr val="lt1"/>
+          </a:fontRef>
+        </p:style>
+        <p:txBody>
+          <a:bodyPr rtlCol="0" anchor="ctr"/>
+          <a:lstStyle/>
+          <a:p>
+            <a:pPr algn="ctr"/>
+            <a:r>
+              <a:rPr lang="en-US" dirty="0"/>
+              <a:t>In each cluster find the standardized tumor name closest to each cluster member. </a:t>
+            </a:r>
+          </a:p>
+        </p:txBody>
+      </p:sp>
+      <p:sp>
+        <p:nvSpPr>
+          <p:cNvPr id="29" name="Right Arrow 28">
+            <a:extLst>
+              <a:ext uri="{FF2B5EF4-FFF2-40B4-BE49-F238E27FC236}">
+                <a16:creationId xmlns:a16="http://schemas.microsoft.com/office/drawing/2014/main" id="{84CCA57B-3C8C-41BE-8EA3-47D5E0FB7917}"/>
+              </a:ext>
+            </a:extLst>
+          </p:cNvPr>
+          <p:cNvSpPr/>
+          <p:nvPr/>
+        </p:nvSpPr>
+        <p:spPr>
+          <a:xfrm>
+            <a:off x="1391489" y="1102900"/>
+            <a:ext cx="1025495" cy="529839"/>
+          </a:xfrm>
+          <a:prstGeom prst="rightArrow">
+            <a:avLst/>
+          </a:prstGeom>
+        </p:spPr>
+        <p:style>
+          <a:lnRef idx="2">
+            <a:schemeClr val="accent1">
+              <a:shade val="15000"/>
+            </a:schemeClr>
+          </a:lnRef>
+          <a:fillRef idx="1">
+            <a:schemeClr val="accent1"/>
+          </a:fillRef>
+          <a:effectRef idx="0">
+            <a:schemeClr val="accent1"/>
+          </a:effectRef>
+          <a:fontRef idx="minor">
+            <a:schemeClr val="lt1"/>
+          </a:fontRef>
+        </p:style>
+        <p:txBody>
+          <a:bodyPr rtlCol="0" anchor="ctr"/>
+          <a:lstStyle/>
+          <a:p>
+            <a:pPr algn="ctr"/>
+            <a:endParaRPr lang="en-US"/>
+          </a:p>
+        </p:txBody>
+      </p:sp>
+      <p:sp>
+        <p:nvSpPr>
+          <p:cNvPr id="30" name="Right Arrow 29">
+            <a:extLst>
+              <a:ext uri="{FF2B5EF4-FFF2-40B4-BE49-F238E27FC236}">
+                <a16:creationId xmlns:a16="http://schemas.microsoft.com/office/drawing/2014/main" id="{81EB917E-25B1-AE1F-4FAD-C37EBF6AB563}"/>
+              </a:ext>
+            </a:extLst>
+          </p:cNvPr>
+          <p:cNvSpPr/>
+          <p:nvPr/>
+        </p:nvSpPr>
+        <p:spPr>
+          <a:xfrm rot="19419849">
+            <a:off x="1657498" y="2230109"/>
+            <a:ext cx="1025495" cy="529839"/>
+          </a:xfrm>
+          <a:prstGeom prst="rightArrow">
+            <a:avLst/>
+          </a:prstGeom>
+        </p:spPr>
+        <p:style>
+          <a:lnRef idx="2">
+            <a:schemeClr val="accent1">
+              <a:shade val="15000"/>
+            </a:schemeClr>
+          </a:lnRef>
+          <a:fillRef idx="1">
+            <a:schemeClr val="accent1"/>
+          </a:fillRef>
+          <a:effectRef idx="0">
+            <a:schemeClr val="accent1"/>
+          </a:effectRef>
+          <a:fontRef idx="minor">
+            <a:schemeClr val="lt1"/>
+          </a:fontRef>
+        </p:style>
+        <p:txBody>
+          <a:bodyPr rtlCol="0" anchor="ctr"/>
+          <a:lstStyle/>
+          <a:p>
+            <a:pPr algn="ctr"/>
+            <a:endParaRPr lang="en-US"/>
+          </a:p>
+        </p:txBody>
+      </p:sp>
+      <p:sp>
+        <p:nvSpPr>
+          <p:cNvPr id="31" name="Right Arrow 30">
+            <a:extLst>
+              <a:ext uri="{FF2B5EF4-FFF2-40B4-BE49-F238E27FC236}">
+                <a16:creationId xmlns:a16="http://schemas.microsoft.com/office/drawing/2014/main" id="{E25ED098-021B-C1C9-CF51-C674013DF8EA}"/>
+              </a:ext>
+            </a:extLst>
+          </p:cNvPr>
+          <p:cNvSpPr/>
+          <p:nvPr/>
+        </p:nvSpPr>
+        <p:spPr>
+          <a:xfrm rot="5400000">
+            <a:off x="3831138" y="3593062"/>
+            <a:ext cx="717906" cy="554994"/>
+          </a:xfrm>
+          <a:prstGeom prst="rightArrow">
+            <a:avLst/>
+          </a:prstGeom>
+        </p:spPr>
+        <p:style>
+          <a:lnRef idx="2">
+            <a:schemeClr val="accent1">
+              <a:shade val="15000"/>
+            </a:schemeClr>
+          </a:lnRef>
+          <a:fillRef idx="1">
+            <a:schemeClr val="accent1"/>
+          </a:fillRef>
+          <a:effectRef idx="0">
+            <a:schemeClr val="accent1"/>
+          </a:effectRef>
+          <a:fontRef idx="minor">
+            <a:schemeClr val="lt1"/>
+          </a:fontRef>
+        </p:style>
+        <p:txBody>
+          <a:bodyPr rtlCol="0" anchor="ctr"/>
+          <a:lstStyle/>
+          <a:p>
+            <a:pPr algn="ctr"/>
+            <a:endParaRPr lang="en-US"/>
+          </a:p>
+        </p:txBody>
+      </p:sp>
+      <p:sp>
+        <p:nvSpPr>
+          <p:cNvPr id="33" name="Rectangle 32">
+            <a:extLst>
+              <a:ext uri="{FF2B5EF4-FFF2-40B4-BE49-F238E27FC236}">
+                <a16:creationId xmlns:a16="http://schemas.microsoft.com/office/drawing/2014/main" id="{D6338E01-895B-58AC-0BC0-60DBE35F15B6}"/>
+              </a:ext>
+            </a:extLst>
+          </p:cNvPr>
+          <p:cNvSpPr/>
+          <p:nvPr/>
+        </p:nvSpPr>
+        <p:spPr>
+          <a:xfrm>
+            <a:off x="7002398" y="3418295"/>
+            <a:ext cx="3951340" cy="1073935"/>
+          </a:xfrm>
+          <a:prstGeom prst="rect">
+            <a:avLst/>
+          </a:prstGeom>
+          <a:solidFill>
+            <a:schemeClr val="accent3">
+              <a:lumMod val="60000"/>
+              <a:lumOff val="40000"/>
+            </a:schemeClr>
+          </a:solidFill>
+        </p:spPr>
+        <p:style>
+          <a:lnRef idx="2">
+            <a:schemeClr val="accent1">
+              <a:shade val="15000"/>
+            </a:schemeClr>
+          </a:lnRef>
+          <a:fillRef idx="1">
+            <a:schemeClr val="accent1"/>
+          </a:fillRef>
+          <a:effectRef idx="0">
+            <a:schemeClr val="accent1"/>
+          </a:effectRef>
+          <a:fontRef idx="minor">
+            <a:schemeClr val="lt1"/>
+          </a:fontRef>
+        </p:style>
+        <p:txBody>
+          <a:bodyPr rtlCol="0" anchor="ctr"/>
+          <a:lstStyle/>
+          <a:p>
+            <a:pPr algn="ctr"/>
+            <a:r>
+              <a:rPr lang="en-US" dirty="0"/>
+              <a:t>If a standardized name represents majority of the cluster member assign it as the standardized name for all cluster members.</a:t>
+            </a:r>
+          </a:p>
+        </p:txBody>
+      </p:sp>
+      <p:sp>
+        <p:nvSpPr>
+          <p:cNvPr id="34" name="Rectangle 33">
+            <a:extLst>
+              <a:ext uri="{FF2B5EF4-FFF2-40B4-BE49-F238E27FC236}">
+                <a16:creationId xmlns:a16="http://schemas.microsoft.com/office/drawing/2014/main" id="{3097155B-A889-68CD-94F7-A29B8338098A}"/>
+              </a:ext>
+            </a:extLst>
+          </p:cNvPr>
+          <p:cNvSpPr/>
+          <p:nvPr/>
+        </p:nvSpPr>
+        <p:spPr>
+          <a:xfrm>
+            <a:off x="7030939" y="4701874"/>
+            <a:ext cx="3951339" cy="860083"/>
+          </a:xfrm>
+          <a:prstGeom prst="rect">
+            <a:avLst/>
+          </a:prstGeom>
+          <a:solidFill>
+            <a:schemeClr val="accent3">
+              <a:lumMod val="60000"/>
+              <a:lumOff val="40000"/>
+            </a:schemeClr>
+          </a:solidFill>
+        </p:spPr>
+        <p:style>
+          <a:lnRef idx="2">
+            <a:schemeClr val="accent1">
+              <a:shade val="15000"/>
+            </a:schemeClr>
+          </a:lnRef>
+          <a:fillRef idx="1">
+            <a:schemeClr val="accent1"/>
+          </a:fillRef>
+          <a:effectRef idx="0">
+            <a:schemeClr val="accent1"/>
+          </a:effectRef>
+          <a:fontRef idx="minor">
+            <a:schemeClr val="lt1"/>
+          </a:fontRef>
+        </p:style>
+        <p:txBody>
+          <a:bodyPr rtlCol="0" anchor="ctr"/>
+          <a:lstStyle/>
+          <a:p>
+            <a:pPr algn="ctr"/>
+            <a:r>
+              <a:rPr lang="en-US" dirty="0"/>
+              <a:t>Otherwise, assign cluster members to nearest standardized term</a:t>
+            </a:r>
+          </a:p>
+        </p:txBody>
+      </p:sp>
+      <p:sp>
+        <p:nvSpPr>
+          <p:cNvPr id="36" name="Right Arrow 35">
+            <a:extLst>
+              <a:ext uri="{FF2B5EF4-FFF2-40B4-BE49-F238E27FC236}">
+                <a16:creationId xmlns:a16="http://schemas.microsoft.com/office/drawing/2014/main" id="{D9BC9283-53DA-ACD5-5130-2458D7B043CB}"/>
+              </a:ext>
+            </a:extLst>
+          </p:cNvPr>
+          <p:cNvSpPr/>
+          <p:nvPr/>
+        </p:nvSpPr>
+        <p:spPr>
+          <a:xfrm>
+            <a:off x="6132670" y="4398806"/>
+            <a:ext cx="717906" cy="554994"/>
+          </a:xfrm>
+          <a:prstGeom prst="rightArrow">
+            <a:avLst/>
+          </a:prstGeom>
+        </p:spPr>
+        <p:style>
+          <a:lnRef idx="2">
+            <a:schemeClr val="accent1">
+              <a:shade val="15000"/>
+            </a:schemeClr>
+          </a:lnRef>
+          <a:fillRef idx="1">
+            <a:schemeClr val="accent1"/>
+          </a:fillRef>
+          <a:effectRef idx="0">
+            <a:schemeClr val="accent1"/>
+          </a:effectRef>
+          <a:fontRef idx="minor">
+            <a:schemeClr val="lt1"/>
+          </a:fontRef>
+        </p:style>
+        <p:txBody>
+          <a:bodyPr rtlCol="0" anchor="ctr"/>
+          <a:lstStyle/>
+          <a:p>
+            <a:pPr algn="ctr"/>
+            <a:endParaRPr lang="en-US"/>
+          </a:p>
+        </p:txBody>
+      </p:sp>
+    </p:spTree>
+    <p:extLst>
+      <p:ext uri="{BB962C8B-B14F-4D97-AF65-F5344CB8AC3E}">
+        <p14:creationId xmlns:p14="http://schemas.microsoft.com/office/powerpoint/2010/main" val="2050892151"/>
+      </p:ext>
+    </p:extLst>
+  </p:cSld>
+  <p:clrMapOvr>
+    <a:masterClrMapping/>
+  </p:clrMapOvr>
+</p:sld>
+</file>
+
+<file path=ppt/slides/slide12.xml><?xml version="1.0" encoding="utf-8"?>
+<p:sld xmlns:a="http://schemas.openxmlformats.org/drawingml/2006/main" xmlns:r="http://schemas.openxmlformats.org/officeDocument/2006/relationships" xmlns:p="http://schemas.openxmlformats.org/presentationml/2006/main">
+  <p:cSld>
+    <p:spTree>
+      <p:nvGrpSpPr>
+        <p:cNvPr id="1" name="">
+          <a:extLst>
+            <a:ext uri="{FF2B5EF4-FFF2-40B4-BE49-F238E27FC236}">
+              <a16:creationId xmlns:a16="http://schemas.microsoft.com/office/drawing/2014/main" id="{D3EC1EB9-9B68-70A2-3AE0-52EF6172BBB7}"/>
+            </a:ext>
+          </a:extLst>
+        </p:cNvPr>
+        <p:cNvGrpSpPr/>
+        <p:nvPr/>
+      </p:nvGrpSpPr>
+      <p:grpSpPr>
+        <a:xfrm>
+          <a:off x="0" y="0"/>
+          <a:ext cx="0" cy="0"/>
+          <a:chOff x="0" y="0"/>
+          <a:chExt cx="0" cy="0"/>
+        </a:xfrm>
+      </p:grpSpPr>
+      <p:sp>
+        <p:nvSpPr>
+          <p:cNvPr id="2" name="Title 1">
+            <a:extLst>
+              <a:ext uri="{FF2B5EF4-FFF2-40B4-BE49-F238E27FC236}">
+                <a16:creationId xmlns:a16="http://schemas.microsoft.com/office/drawing/2014/main" id="{1C261B09-5FE2-1F2B-B4DA-07731E7651A6}"/>
+              </a:ext>
+            </a:extLst>
+          </p:cNvPr>
+          <p:cNvSpPr>
+            <a:spLocks noGrp="1"/>
+          </p:cNvSpPr>
+          <p:nvPr>
+            <p:ph type="title"/>
+          </p:nvPr>
+        </p:nvSpPr>
+        <p:spPr>
+          <a:xfrm>
+            <a:off x="87086" y="21771"/>
+            <a:ext cx="10651402" cy="1143000"/>
+          </a:xfrm>
+        </p:spPr>
+        <p:txBody>
+          <a:bodyPr/>
+          <a:lstStyle/>
+          <a:p>
+            <a:r>
+              <a:rPr lang="en-US" dirty="0"/>
+              <a:t>Tumor Name Standardization		</a:t>
+            </a:r>
+          </a:p>
+        </p:txBody>
+      </p:sp>
+      <p:sp>
+        <p:nvSpPr>
+          <p:cNvPr id="3" name="Content Placeholder 2">
+            <a:extLst>
+              <a:ext uri="{FF2B5EF4-FFF2-40B4-BE49-F238E27FC236}">
+                <a16:creationId xmlns:a16="http://schemas.microsoft.com/office/drawing/2014/main" id="{746048D8-729C-FD55-857D-1B1119FA6E74}"/>
+              </a:ext>
+            </a:extLst>
+          </p:cNvPr>
+          <p:cNvSpPr>
+            <a:spLocks noGrp="1"/>
+          </p:cNvSpPr>
+          <p:nvPr>
+            <p:ph idx="1"/>
+          </p:nvPr>
+        </p:nvSpPr>
+        <p:spPr>
+          <a:xfrm>
+            <a:off x="179670" y="1164771"/>
+            <a:ext cx="11261215" cy="4484914"/>
+          </a:xfrm>
+        </p:spPr>
+        <p:txBody>
+          <a:bodyPr>
+            <a:normAutofit/>
+          </a:bodyPr>
+          <a:lstStyle/>
+          <a:p>
+            <a:pPr algn="just"/>
+            <a:r>
+              <a:rPr lang="en-US" sz="1800" dirty="0">
+                <a:solidFill>
+                  <a:schemeClr val="tx1"/>
+                </a:solidFill>
+                <a:latin typeface="+mn-lt"/>
+                <a:cs typeface="+mn-cs"/>
+              </a:rPr>
+              <a:t>Edit distances: are a way of measuring how different two strings (sequences of characters) are. The edit distance is the minimum number of operations needed to transform one string into another. E.g. </a:t>
+            </a:r>
+            <a:r>
+              <a:rPr lang="en-US" sz="1800" dirty="0" err="1">
+                <a:solidFill>
+                  <a:schemeClr val="tx1"/>
+                </a:solidFill>
+                <a:latin typeface="+mn-lt"/>
+                <a:cs typeface="+mn-cs"/>
+              </a:rPr>
+              <a:t>Levenshtein</a:t>
+            </a:r>
+            <a:r>
+              <a:rPr lang="en-US" sz="1800" dirty="0">
+                <a:solidFill>
+                  <a:schemeClr val="tx1"/>
+                </a:solidFill>
+                <a:latin typeface="+mn-lt"/>
+                <a:cs typeface="+mn-cs"/>
+              </a:rPr>
+              <a:t> , cosine, </a:t>
+            </a:r>
+            <a:r>
+              <a:rPr lang="en-US" sz="1800" dirty="0" err="1">
+                <a:solidFill>
+                  <a:schemeClr val="tx1"/>
+                </a:solidFill>
+                <a:latin typeface="+mn-lt"/>
+                <a:cs typeface="+mn-cs"/>
+              </a:rPr>
+              <a:t>jarro-winkler</a:t>
+            </a:r>
+            <a:r>
+              <a:rPr lang="en-US" sz="1800" dirty="0">
+                <a:solidFill>
+                  <a:schemeClr val="tx1"/>
+                </a:solidFill>
+                <a:latin typeface="+mn-lt"/>
+                <a:cs typeface="+mn-cs"/>
+              </a:rPr>
+              <a:t> etc. </a:t>
+            </a:r>
+          </a:p>
+          <a:p>
+            <a:pPr algn="just"/>
+            <a:endParaRPr lang="en-US" sz="1800" dirty="0">
+              <a:solidFill>
+                <a:schemeClr val="tx1"/>
+              </a:solidFill>
+              <a:latin typeface="+mn-lt"/>
+              <a:cs typeface="+mn-cs"/>
+            </a:endParaRPr>
+          </a:p>
+          <a:p>
+            <a:r>
+              <a:rPr lang="en-US" sz="1800" dirty="0">
+                <a:solidFill>
+                  <a:schemeClr val="tx1"/>
+                </a:solidFill>
+                <a:latin typeface="+mn-lt"/>
+                <a:cs typeface="+mn-cs"/>
+              </a:rPr>
+              <a:t>Text Embeddings: Text embeddings are numerical vector representations of text — words, phrases, or entire documents — that capture their meaning and semantic relationships in a high-dimensional space.</a:t>
+            </a:r>
+          </a:p>
+          <a:p>
+            <a:pPr lvl="1"/>
+            <a:r>
+              <a:rPr lang="en-US" sz="1400" dirty="0">
+                <a:solidFill>
+                  <a:schemeClr val="tx1"/>
+                </a:solidFill>
+                <a:latin typeface="+mn-lt"/>
+                <a:cs typeface="+mn-cs"/>
+              </a:rPr>
+              <a:t>Similar meanings → vectors that are close together</a:t>
+            </a:r>
+            <a:br>
+              <a:rPr lang="en-US" sz="1400" dirty="0">
+                <a:solidFill>
+                  <a:schemeClr val="tx1"/>
+                </a:solidFill>
+                <a:latin typeface="+mn-lt"/>
+                <a:cs typeface="+mn-cs"/>
+              </a:rPr>
+            </a:br>
+            <a:r>
+              <a:rPr lang="en-US" sz="1400" dirty="0">
+                <a:solidFill>
+                  <a:schemeClr val="tx1"/>
+                </a:solidFill>
+                <a:latin typeface="+mn-lt"/>
+                <a:cs typeface="+mn-cs"/>
+              </a:rPr>
+              <a:t>Different meanings → vectors that are far apart</a:t>
+            </a:r>
+          </a:p>
+          <a:p>
+            <a:pPr lvl="1"/>
+            <a:endParaRPr lang="en-US" sz="1800" dirty="0">
+              <a:solidFill>
+                <a:schemeClr val="tx1"/>
+              </a:solidFill>
+              <a:latin typeface="+mn-lt"/>
+            </a:endParaRPr>
+          </a:p>
+          <a:p>
+            <a:r>
+              <a:rPr lang="en-US" sz="1800" dirty="0">
+                <a:solidFill>
+                  <a:schemeClr val="tx1"/>
+                </a:solidFill>
+                <a:latin typeface="+mn-lt"/>
+                <a:cs typeface="+mn-cs"/>
+              </a:rPr>
+              <a:t>Text Embeddings: generated by models based on NLP (Word2Vec, </a:t>
+            </a:r>
+            <a:r>
+              <a:rPr lang="en-US" sz="1800" dirty="0" err="1">
+                <a:solidFill>
+                  <a:schemeClr val="tx1"/>
+                </a:solidFill>
+                <a:latin typeface="+mn-lt"/>
+                <a:cs typeface="+mn-cs"/>
+              </a:rPr>
+              <a:t>GloVe</a:t>
+            </a:r>
+            <a:r>
+              <a:rPr lang="en-US" sz="1800" dirty="0">
+                <a:solidFill>
+                  <a:schemeClr val="tx1"/>
+                </a:solidFill>
+                <a:latin typeface="+mn-lt"/>
+                <a:cs typeface="+mn-cs"/>
+              </a:rPr>
+              <a:t>), transformers (</a:t>
+            </a:r>
+            <a:r>
+              <a:rPr lang="en-US" sz="1800" dirty="0" err="1">
+                <a:solidFill>
+                  <a:schemeClr val="tx1"/>
+                </a:solidFill>
+                <a:latin typeface="+mn-lt"/>
+                <a:cs typeface="+mn-cs"/>
+              </a:rPr>
+              <a:t>BioBERT</a:t>
+            </a:r>
+            <a:r>
+              <a:rPr lang="en-US" sz="1800" dirty="0">
+                <a:solidFill>
+                  <a:schemeClr val="tx1"/>
+                </a:solidFill>
+                <a:latin typeface="+mn-lt"/>
+                <a:cs typeface="+mn-cs"/>
+              </a:rPr>
+              <a:t>, </a:t>
+            </a:r>
+            <a:r>
+              <a:rPr lang="en-US" sz="1800" dirty="0" err="1">
+                <a:solidFill>
+                  <a:schemeClr val="tx1"/>
+                </a:solidFill>
+                <a:latin typeface="+mn-lt"/>
+                <a:cs typeface="+mn-cs"/>
+              </a:rPr>
+              <a:t>BioGPT</a:t>
+            </a:r>
+            <a:r>
+              <a:rPr lang="en-US" sz="1800" dirty="0">
+                <a:solidFill>
+                  <a:schemeClr val="tx1"/>
+                </a:solidFill>
+                <a:latin typeface="+mn-lt"/>
+                <a:cs typeface="+mn-cs"/>
+              </a:rPr>
+              <a:t>) and LLMs (Llama, Open AI, Cohere, </a:t>
+            </a:r>
+            <a:r>
+              <a:rPr lang="en-US" sz="1800" dirty="0" err="1">
+                <a:solidFill>
+                  <a:schemeClr val="tx1"/>
+                </a:solidFill>
+                <a:latin typeface="+mn-lt"/>
+                <a:cs typeface="+mn-cs"/>
+              </a:rPr>
+              <a:t>miniLM</a:t>
+            </a:r>
+            <a:r>
+              <a:rPr lang="en-US" sz="1800" dirty="0">
+                <a:solidFill>
+                  <a:schemeClr val="tx1"/>
+                </a:solidFill>
+                <a:latin typeface="+mn-lt"/>
+                <a:cs typeface="+mn-cs"/>
+              </a:rPr>
+              <a:t>).</a:t>
+            </a:r>
+          </a:p>
+          <a:p>
+            <a:endParaRPr lang="en-US" sz="1800" dirty="0">
+              <a:solidFill>
+                <a:schemeClr val="tx1"/>
+              </a:solidFill>
+              <a:latin typeface="+mn-lt"/>
+              <a:cs typeface="+mn-cs"/>
+            </a:endParaRPr>
+          </a:p>
+        </p:txBody>
+      </p:sp>
+      <p:sp>
+        <p:nvSpPr>
+          <p:cNvPr id="4" name="Slide Number Placeholder 3">
+            <a:extLst>
+              <a:ext uri="{FF2B5EF4-FFF2-40B4-BE49-F238E27FC236}">
+                <a16:creationId xmlns:a16="http://schemas.microsoft.com/office/drawing/2014/main" id="{329BE4E6-4BC0-54DC-4146-6C32F8532DB7}"/>
+              </a:ext>
+            </a:extLst>
+          </p:cNvPr>
+          <p:cNvSpPr>
+            <a:spLocks noGrp="1"/>
+          </p:cNvSpPr>
+          <p:nvPr>
+            <p:ph type="sldNum" sz="quarter" idx="12"/>
+          </p:nvPr>
+        </p:nvSpPr>
+        <p:spPr/>
+        <p:txBody>
+          <a:bodyPr/>
+          <a:lstStyle/>
+          <a:p>
+            <a:fld id="{AD40181A-01B0-4CB8-8614-1473649F6741}" type="slidenum">
+              <a:rPr lang="en-US" smtClean="0">
+                <a:solidFill>
+                  <a:schemeClr val="bg1"/>
+                </a:solidFill>
+              </a:rPr>
+              <a:t>12</a:t>
+            </a:fld>
+            <a:endParaRPr lang="en-US" dirty="0">
+              <a:solidFill>
+                <a:schemeClr val="bg1"/>
+              </a:solidFill>
+            </a:endParaRPr>
+          </a:p>
+        </p:txBody>
+      </p:sp>
+    </p:spTree>
+    <p:extLst>
+      <p:ext uri="{BB962C8B-B14F-4D97-AF65-F5344CB8AC3E}">
+        <p14:creationId xmlns:p14="http://schemas.microsoft.com/office/powerpoint/2010/main" val="3534941817"/>
+      </p:ext>
+    </p:extLst>
+  </p:cSld>
+  <p:clrMapOvr>
+    <a:masterClrMapping/>
+  </p:clrMapOvr>
+</p:sld>
+</file>
+
+<file path=ppt/slides/slide13.xml><?xml version="1.0" encoding="utf-8"?>
+<p:sld xmlns:a="http://schemas.openxmlformats.org/drawingml/2006/main" xmlns:r="http://schemas.openxmlformats.org/officeDocument/2006/relationships" xmlns:p="http://schemas.openxmlformats.org/presentationml/2006/main">
+  <p:cSld>
+    <p:spTree>
+      <p:nvGrpSpPr>
+        <p:cNvPr id="1" name="">
+          <a:extLst>
+            <a:ext uri="{FF2B5EF4-FFF2-40B4-BE49-F238E27FC236}">
+              <a16:creationId xmlns:a16="http://schemas.microsoft.com/office/drawing/2014/main" id="{86A6F464-9BC2-59B5-6597-4C3F2CDFD51F}"/>
+            </a:ext>
+          </a:extLst>
+        </p:cNvPr>
+        <p:cNvGrpSpPr/>
+        <p:nvPr/>
+      </p:nvGrpSpPr>
+      <p:grpSpPr>
+        <a:xfrm>
+          <a:off x="0" y="0"/>
+          <a:ext cx="0" cy="0"/>
+          <a:chOff x="0" y="0"/>
+          <a:chExt cx="0" cy="0"/>
+        </a:xfrm>
+      </p:grpSpPr>
+      <p:sp>
+        <p:nvSpPr>
+          <p:cNvPr id="2" name="Slide Number Placeholder 1">
+            <a:extLst>
+              <a:ext uri="{FF2B5EF4-FFF2-40B4-BE49-F238E27FC236}">
+                <a16:creationId xmlns:a16="http://schemas.microsoft.com/office/drawing/2014/main" id="{56DBE8F5-57CD-3A29-C0B3-CB97D1180950}"/>
+              </a:ext>
+            </a:extLst>
+          </p:cNvPr>
+          <p:cNvSpPr>
+            <a:spLocks noGrp="1"/>
+          </p:cNvSpPr>
+          <p:nvPr>
+            <p:ph type="sldNum" sz="quarter" idx="12"/>
+          </p:nvPr>
+        </p:nvSpPr>
+        <p:spPr/>
+        <p:txBody>
+          <a:bodyPr/>
+          <a:lstStyle/>
+          <a:p>
+            <a:fld id="{AD40181A-01B0-4CB8-8614-1473649F6741}" type="slidenum">
+              <a:rPr lang="en-US" smtClean="0">
+                <a:solidFill>
+                  <a:srgbClr val="FFFFFE"/>
+                </a:solidFill>
+              </a:rPr>
+              <a:t>13</a:t>
+            </a:fld>
+            <a:endParaRPr lang="en-US" dirty="0">
+              <a:solidFill>
+                <a:srgbClr val="FFFFFE"/>
+              </a:solidFill>
+            </a:endParaRPr>
+          </a:p>
+        </p:txBody>
+      </p:sp>
+      <p:sp>
+        <p:nvSpPr>
+          <p:cNvPr id="3" name="Title 2">
+            <a:extLst>
+              <a:ext uri="{FF2B5EF4-FFF2-40B4-BE49-F238E27FC236}">
+                <a16:creationId xmlns:a16="http://schemas.microsoft.com/office/drawing/2014/main" id="{23D9419A-DE97-CD7A-A21A-0DC56A367EDA}"/>
+              </a:ext>
+            </a:extLst>
+          </p:cNvPr>
+          <p:cNvSpPr>
+            <a:spLocks noGrp="1"/>
+          </p:cNvSpPr>
+          <p:nvPr>
+            <p:ph type="title"/>
+          </p:nvPr>
+        </p:nvSpPr>
+        <p:spPr>
+          <a:xfrm>
+            <a:off x="0" y="-294409"/>
+            <a:ext cx="11874374" cy="1279750"/>
+          </a:xfrm>
+        </p:spPr>
+        <p:txBody>
+          <a:bodyPr/>
+          <a:lstStyle/>
+          <a:p>
+            <a:r>
+              <a:rPr lang="en-US" dirty="0"/>
+              <a:t>CANTOS : Tumor Name Standardization phase</a:t>
+            </a:r>
+          </a:p>
+        </p:txBody>
+      </p:sp>
+      <p:pic>
+        <p:nvPicPr>
+          <p:cNvPr id="5" name="Graphic 4" descr="Document outline">
+            <a:extLst>
+              <a:ext uri="{FF2B5EF4-FFF2-40B4-BE49-F238E27FC236}">
+                <a16:creationId xmlns:a16="http://schemas.microsoft.com/office/drawing/2014/main" id="{B1274813-20A4-1606-A389-6B2E381AC680}"/>
+              </a:ext>
+            </a:extLst>
+          </p:cNvPr>
+          <p:cNvPicPr>
+            <a:picLocks noChangeAspect="1"/>
+          </p:cNvPicPr>
+          <p:nvPr/>
+        </p:nvPicPr>
+        <p:blipFill>
+          <a:blip r:embed="rId2">
+            <a:extLst>
+              <a:ext uri="{96DAC541-7B7A-43D3-8B79-37D633B846F1}">
+                <asvg:svgBlip xmlns:asvg="http://schemas.microsoft.com/office/drawing/2016/SVG/main" r:embed="rId3"/>
+              </a:ext>
+            </a:extLst>
+          </a:blip>
+          <a:stretch>
+            <a:fillRect/>
+          </a:stretch>
+        </p:blipFill>
+        <p:spPr>
+          <a:xfrm>
+            <a:off x="85015" y="716462"/>
+            <a:ext cx="1122081" cy="1122081"/>
+          </a:xfrm>
+          <a:prstGeom prst="rect">
+            <a:avLst/>
+          </a:prstGeom>
+        </p:spPr>
+      </p:pic>
+      <p:sp>
+        <p:nvSpPr>
+          <p:cNvPr id="6" name="TextBox 5">
+            <a:extLst>
+              <a:ext uri="{FF2B5EF4-FFF2-40B4-BE49-F238E27FC236}">
+                <a16:creationId xmlns:a16="http://schemas.microsoft.com/office/drawing/2014/main" id="{EC885851-A36F-18EE-0542-BF2BF98804E4}"/>
+              </a:ext>
+            </a:extLst>
+          </p:cNvPr>
+          <p:cNvSpPr txBox="1"/>
+          <p:nvPr/>
+        </p:nvSpPr>
+        <p:spPr>
+          <a:xfrm>
+            <a:off x="26800" y="1834241"/>
+            <a:ext cx="1877437" cy="646331"/>
+          </a:xfrm>
+          <a:prstGeom prst="rect">
+            <a:avLst/>
+          </a:prstGeom>
+          <a:noFill/>
+        </p:spPr>
+        <p:txBody>
+          <a:bodyPr wrap="none" rtlCol="0">
+            <a:spAutoFit/>
+          </a:bodyPr>
+          <a:lstStyle/>
+          <a:p>
+            <a:r>
+              <a:rPr lang="en-US" dirty="0">
+                <a:solidFill>
+                  <a:schemeClr val="bg2">
+                    <a:lumMod val="50000"/>
+                  </a:schemeClr>
+                </a:solidFill>
+              </a:rPr>
+              <a:t>Unstandardized </a:t>
+            </a:r>
+            <a:br>
+              <a:rPr lang="en-US" dirty="0">
+                <a:solidFill>
+                  <a:schemeClr val="bg2">
+                    <a:lumMod val="50000"/>
+                  </a:schemeClr>
+                </a:solidFill>
+              </a:rPr>
+            </a:br>
+            <a:r>
+              <a:rPr lang="en-US" dirty="0">
+                <a:solidFill>
+                  <a:schemeClr val="bg2">
+                    <a:lumMod val="50000"/>
+                  </a:schemeClr>
+                </a:solidFill>
+              </a:rPr>
+              <a:t>Tumor </a:t>
+            </a:r>
+            <a:r>
+              <a:rPr lang="en-US" dirty="0" err="1">
+                <a:solidFill>
+                  <a:schemeClr val="bg2">
+                    <a:lumMod val="50000"/>
+                  </a:schemeClr>
+                </a:solidFill>
+              </a:rPr>
+              <a:t>List.csv</a:t>
+            </a:r>
+            <a:endParaRPr lang="en-US" dirty="0">
+              <a:solidFill>
+                <a:schemeClr val="bg2">
+                  <a:lumMod val="50000"/>
+                </a:schemeClr>
+              </a:solidFill>
+            </a:endParaRPr>
+          </a:p>
+        </p:txBody>
+      </p:sp>
+      <p:pic>
+        <p:nvPicPr>
+          <p:cNvPr id="9" name="Graphic 8" descr="Database outline">
+            <a:extLst>
+              <a:ext uri="{FF2B5EF4-FFF2-40B4-BE49-F238E27FC236}">
+                <a16:creationId xmlns:a16="http://schemas.microsoft.com/office/drawing/2014/main" id="{9B7A1ED1-AF7D-2EAA-FDC9-7C40132B7AE4}"/>
+              </a:ext>
+            </a:extLst>
+          </p:cNvPr>
+          <p:cNvPicPr>
+            <a:picLocks noChangeAspect="1"/>
+          </p:cNvPicPr>
+          <p:nvPr/>
+        </p:nvPicPr>
+        <p:blipFill>
+          <a:blip r:embed="rId4">
+            <a:extLst>
+              <a:ext uri="{96DAC541-7B7A-43D3-8B79-37D633B846F1}">
+                <asvg:svgBlip xmlns:asvg="http://schemas.microsoft.com/office/drawing/2016/SVG/main" r:embed="rId5"/>
+              </a:ext>
+            </a:extLst>
+          </a:blip>
+          <a:stretch>
+            <a:fillRect/>
+          </a:stretch>
+        </p:blipFill>
+        <p:spPr>
+          <a:xfrm>
+            <a:off x="191306" y="2471051"/>
+            <a:ext cx="1244416" cy="1244416"/>
+          </a:xfrm>
+          <a:prstGeom prst="rect">
+            <a:avLst/>
+          </a:prstGeom>
+        </p:spPr>
+      </p:pic>
+      <p:sp>
+        <p:nvSpPr>
+          <p:cNvPr id="10" name="TextBox 9">
+            <a:extLst>
+              <a:ext uri="{FF2B5EF4-FFF2-40B4-BE49-F238E27FC236}">
+                <a16:creationId xmlns:a16="http://schemas.microsoft.com/office/drawing/2014/main" id="{AFB1358E-8A86-AD6C-27A6-FA2CDE97CB51}"/>
+              </a:ext>
+            </a:extLst>
+          </p:cNvPr>
+          <p:cNvSpPr txBox="1"/>
+          <p:nvPr/>
+        </p:nvSpPr>
+        <p:spPr>
+          <a:xfrm>
+            <a:off x="14874" y="3644757"/>
+            <a:ext cx="1765922" cy="923330"/>
+          </a:xfrm>
+          <a:prstGeom prst="rect">
+            <a:avLst/>
+          </a:prstGeom>
+          <a:noFill/>
+        </p:spPr>
+        <p:txBody>
+          <a:bodyPr wrap="square" rtlCol="0">
+            <a:spAutoFit/>
+          </a:bodyPr>
+          <a:lstStyle/>
+          <a:p>
+            <a:pPr algn="ctr"/>
+            <a:r>
+              <a:rPr lang="en-US" dirty="0">
+                <a:solidFill>
+                  <a:schemeClr val="bg2">
+                    <a:lumMod val="50000"/>
+                  </a:schemeClr>
+                </a:solidFill>
+              </a:rPr>
+              <a:t>WHO Tumor Classification System</a:t>
+            </a:r>
+          </a:p>
+        </p:txBody>
+      </p:sp>
+      <p:sp>
+        <p:nvSpPr>
+          <p:cNvPr id="12" name="Rectangle 11">
+            <a:extLst>
+              <a:ext uri="{FF2B5EF4-FFF2-40B4-BE49-F238E27FC236}">
+                <a16:creationId xmlns:a16="http://schemas.microsoft.com/office/drawing/2014/main" id="{B0BC2DE0-B4D5-9473-5C7D-82C99B381AB9}"/>
+              </a:ext>
+            </a:extLst>
+          </p:cNvPr>
+          <p:cNvSpPr/>
+          <p:nvPr/>
+        </p:nvSpPr>
+        <p:spPr>
+          <a:xfrm>
+            <a:off x="2629512" y="1054229"/>
+            <a:ext cx="2907576" cy="837415"/>
+          </a:xfrm>
+          <a:prstGeom prst="rect">
+            <a:avLst/>
+          </a:prstGeom>
+        </p:spPr>
+        <p:style>
+          <a:lnRef idx="2">
+            <a:schemeClr val="accent1">
+              <a:shade val="15000"/>
+            </a:schemeClr>
+          </a:lnRef>
+          <a:fillRef idx="1">
+            <a:schemeClr val="accent1"/>
+          </a:fillRef>
+          <a:effectRef idx="0">
+            <a:schemeClr val="accent1"/>
+          </a:effectRef>
+          <a:fontRef idx="minor">
+            <a:schemeClr val="lt1"/>
+          </a:fontRef>
+        </p:style>
+        <p:txBody>
+          <a:bodyPr rtlCol="0" anchor="ctr"/>
+          <a:lstStyle/>
+          <a:p>
+            <a:pPr algn="ctr"/>
+            <a:r>
+              <a:rPr lang="en-US" dirty="0"/>
+              <a:t>Compute embedding distance distance</a:t>
+            </a:r>
+          </a:p>
+        </p:txBody>
+      </p:sp>
+      <p:sp>
+        <p:nvSpPr>
+          <p:cNvPr id="24" name="Right Arrow 23">
+            <a:extLst>
+              <a:ext uri="{FF2B5EF4-FFF2-40B4-BE49-F238E27FC236}">
+                <a16:creationId xmlns:a16="http://schemas.microsoft.com/office/drawing/2014/main" id="{AE277EA4-33A9-11F8-A04C-D51F165EEAD3}"/>
+              </a:ext>
+            </a:extLst>
+          </p:cNvPr>
+          <p:cNvSpPr/>
+          <p:nvPr/>
+        </p:nvSpPr>
+        <p:spPr>
+          <a:xfrm>
+            <a:off x="5747659" y="1136938"/>
+            <a:ext cx="1025495" cy="529839"/>
+          </a:xfrm>
+          <a:prstGeom prst="rightArrow">
+            <a:avLst/>
+          </a:prstGeom>
+        </p:spPr>
+        <p:style>
+          <a:lnRef idx="2">
+            <a:schemeClr val="accent1">
+              <a:shade val="15000"/>
+            </a:schemeClr>
+          </a:lnRef>
+          <a:fillRef idx="1">
+            <a:schemeClr val="accent1"/>
+          </a:fillRef>
+          <a:effectRef idx="0">
+            <a:schemeClr val="accent1"/>
+          </a:effectRef>
+          <a:fontRef idx="minor">
+            <a:schemeClr val="lt1"/>
+          </a:fontRef>
+        </p:style>
+        <p:txBody>
+          <a:bodyPr rtlCol="0" anchor="ctr"/>
+          <a:lstStyle/>
+          <a:p>
+            <a:pPr algn="ctr"/>
+            <a:endParaRPr lang="en-US"/>
+          </a:p>
+        </p:txBody>
+      </p:sp>
+      <p:sp>
+        <p:nvSpPr>
+          <p:cNvPr id="25" name="Rectangle 24">
+            <a:extLst>
+              <a:ext uri="{FF2B5EF4-FFF2-40B4-BE49-F238E27FC236}">
+                <a16:creationId xmlns:a16="http://schemas.microsoft.com/office/drawing/2014/main" id="{C39FA034-ED8A-47ED-5412-F1A63511EA3C}"/>
+              </a:ext>
+            </a:extLst>
+          </p:cNvPr>
+          <p:cNvSpPr/>
+          <p:nvPr/>
+        </p:nvSpPr>
+        <p:spPr>
+          <a:xfrm>
+            <a:off x="7030939" y="1001030"/>
+            <a:ext cx="3777046" cy="952919"/>
+          </a:xfrm>
+          <a:prstGeom prst="rect">
+            <a:avLst/>
+          </a:prstGeom>
+          <a:solidFill>
+            <a:schemeClr val="accent3">
+              <a:lumMod val="60000"/>
+              <a:lumOff val="40000"/>
+            </a:schemeClr>
+          </a:solidFill>
+        </p:spPr>
+        <p:style>
+          <a:lnRef idx="2">
+            <a:schemeClr val="accent1">
+              <a:shade val="15000"/>
+            </a:schemeClr>
+          </a:lnRef>
+          <a:fillRef idx="1">
+            <a:schemeClr val="accent1"/>
+          </a:fillRef>
+          <a:effectRef idx="0">
+            <a:schemeClr val="accent1"/>
+          </a:effectRef>
+          <a:fontRef idx="minor">
+            <a:schemeClr val="lt1"/>
+          </a:fontRef>
+        </p:style>
+        <p:txBody>
+          <a:bodyPr rtlCol="0" anchor="ctr"/>
+          <a:lstStyle/>
+          <a:p>
+            <a:pPr algn="ctr"/>
+            <a:r>
+              <a:rPr lang="en-US" dirty="0"/>
+              <a:t>Assign the closest standardized tumor name to the unstandardized tumor name from CTR</a:t>
+            </a:r>
+          </a:p>
+        </p:txBody>
+      </p:sp>
+      <p:sp>
+        <p:nvSpPr>
+          <p:cNvPr id="26" name="Rectangle 25">
+            <a:extLst>
+              <a:ext uri="{FF2B5EF4-FFF2-40B4-BE49-F238E27FC236}">
+                <a16:creationId xmlns:a16="http://schemas.microsoft.com/office/drawing/2014/main" id="{610E811E-8F27-2DFB-ED8D-FD08D41E84C1}"/>
+              </a:ext>
+            </a:extLst>
+          </p:cNvPr>
+          <p:cNvSpPr/>
+          <p:nvPr/>
+        </p:nvSpPr>
+        <p:spPr>
+          <a:xfrm>
+            <a:off x="2600879" y="2650336"/>
+            <a:ext cx="3271171" cy="855955"/>
+          </a:xfrm>
+          <a:prstGeom prst="rect">
+            <a:avLst/>
+          </a:prstGeom>
+        </p:spPr>
+        <p:style>
+          <a:lnRef idx="2">
+            <a:schemeClr val="accent1">
+              <a:shade val="15000"/>
+            </a:schemeClr>
+          </a:lnRef>
+          <a:fillRef idx="1">
+            <a:schemeClr val="accent1"/>
+          </a:fillRef>
+          <a:effectRef idx="0">
+            <a:schemeClr val="accent1"/>
+          </a:effectRef>
+          <a:fontRef idx="minor">
+            <a:schemeClr val="lt1"/>
+          </a:fontRef>
+        </p:style>
+        <p:txBody>
+          <a:bodyPr rtlCol="0" anchor="ctr"/>
+          <a:lstStyle/>
+          <a:p>
+            <a:pPr algn="ctr"/>
+            <a:r>
+              <a:rPr lang="en-US" dirty="0"/>
+              <a:t>Use embedding distance to cluster: Affinity Propagation or </a:t>
+            </a:r>
+            <a:r>
+              <a:rPr lang="en-US" dirty="0" err="1"/>
+              <a:t>KMeans</a:t>
+            </a:r>
+            <a:endParaRPr lang="en-US" dirty="0"/>
+          </a:p>
+        </p:txBody>
+      </p:sp>
+      <p:sp>
+        <p:nvSpPr>
+          <p:cNvPr id="27" name="Right Arrow 26">
+            <a:extLst>
+              <a:ext uri="{FF2B5EF4-FFF2-40B4-BE49-F238E27FC236}">
+                <a16:creationId xmlns:a16="http://schemas.microsoft.com/office/drawing/2014/main" id="{09B512F6-E843-6C7C-F81B-0ED886805E12}"/>
+              </a:ext>
+            </a:extLst>
+          </p:cNvPr>
+          <p:cNvSpPr/>
+          <p:nvPr/>
+        </p:nvSpPr>
+        <p:spPr>
+          <a:xfrm rot="5400000">
+            <a:off x="3820459" y="2017283"/>
+            <a:ext cx="717906" cy="554994"/>
+          </a:xfrm>
+          <a:prstGeom prst="rightArrow">
+            <a:avLst/>
+          </a:prstGeom>
+        </p:spPr>
+        <p:style>
+          <a:lnRef idx="2">
+            <a:schemeClr val="accent1">
+              <a:shade val="15000"/>
+            </a:schemeClr>
+          </a:lnRef>
+          <a:fillRef idx="1">
+            <a:schemeClr val="accent1"/>
+          </a:fillRef>
+          <a:effectRef idx="0">
+            <a:schemeClr val="accent1"/>
+          </a:effectRef>
+          <a:fontRef idx="minor">
+            <a:schemeClr val="lt1"/>
+          </a:fontRef>
+        </p:style>
+        <p:txBody>
+          <a:bodyPr rtlCol="0" anchor="ctr"/>
+          <a:lstStyle/>
+          <a:p>
+            <a:pPr algn="ctr"/>
+            <a:endParaRPr lang="en-US"/>
+          </a:p>
+        </p:txBody>
+      </p:sp>
+      <p:sp>
+        <p:nvSpPr>
+          <p:cNvPr id="28" name="Rectangle 27">
+            <a:extLst>
+              <a:ext uri="{FF2B5EF4-FFF2-40B4-BE49-F238E27FC236}">
+                <a16:creationId xmlns:a16="http://schemas.microsoft.com/office/drawing/2014/main" id="{ACFC6ABB-43B9-D40D-04B3-9932E4470447}"/>
+              </a:ext>
+            </a:extLst>
+          </p:cNvPr>
+          <p:cNvSpPr/>
+          <p:nvPr/>
+        </p:nvSpPr>
+        <p:spPr>
+          <a:xfrm>
+            <a:off x="2296830" y="4297254"/>
+            <a:ext cx="3765164" cy="860083"/>
+          </a:xfrm>
+          <a:prstGeom prst="rect">
+            <a:avLst/>
+          </a:prstGeom>
+        </p:spPr>
+        <p:style>
+          <a:lnRef idx="2">
+            <a:schemeClr val="accent1">
+              <a:shade val="15000"/>
+            </a:schemeClr>
+          </a:lnRef>
+          <a:fillRef idx="1">
+            <a:schemeClr val="accent1"/>
+          </a:fillRef>
+          <a:effectRef idx="0">
+            <a:schemeClr val="accent1"/>
+          </a:effectRef>
+          <a:fontRef idx="minor">
+            <a:schemeClr val="lt1"/>
+          </a:fontRef>
+        </p:style>
+        <p:txBody>
+          <a:bodyPr rtlCol="0" anchor="ctr"/>
+          <a:lstStyle/>
+          <a:p>
+            <a:pPr algn="ctr"/>
+            <a:r>
+              <a:rPr lang="en-US" dirty="0"/>
+              <a:t>In each cluster find the standardized tumor name closest to each cluster member. </a:t>
+            </a:r>
+          </a:p>
+        </p:txBody>
+      </p:sp>
+      <p:sp>
+        <p:nvSpPr>
+          <p:cNvPr id="29" name="Right Arrow 28">
+            <a:extLst>
+              <a:ext uri="{FF2B5EF4-FFF2-40B4-BE49-F238E27FC236}">
+                <a16:creationId xmlns:a16="http://schemas.microsoft.com/office/drawing/2014/main" id="{FC63D67B-2B9C-9572-1165-5BA979E3917D}"/>
+              </a:ext>
+            </a:extLst>
+          </p:cNvPr>
+          <p:cNvSpPr/>
+          <p:nvPr/>
+        </p:nvSpPr>
+        <p:spPr>
+          <a:xfrm>
+            <a:off x="1391489" y="1102900"/>
+            <a:ext cx="1025495" cy="529839"/>
+          </a:xfrm>
+          <a:prstGeom prst="rightArrow">
+            <a:avLst/>
+          </a:prstGeom>
+        </p:spPr>
+        <p:style>
+          <a:lnRef idx="2">
+            <a:schemeClr val="accent1">
+              <a:shade val="15000"/>
+            </a:schemeClr>
+          </a:lnRef>
+          <a:fillRef idx="1">
+            <a:schemeClr val="accent1"/>
+          </a:fillRef>
+          <a:effectRef idx="0">
+            <a:schemeClr val="accent1"/>
+          </a:effectRef>
+          <a:fontRef idx="minor">
+            <a:schemeClr val="lt1"/>
+          </a:fontRef>
+        </p:style>
+        <p:txBody>
+          <a:bodyPr rtlCol="0" anchor="ctr"/>
+          <a:lstStyle/>
+          <a:p>
+            <a:pPr algn="ctr"/>
+            <a:endParaRPr lang="en-US"/>
+          </a:p>
+        </p:txBody>
+      </p:sp>
+      <p:sp>
+        <p:nvSpPr>
+          <p:cNvPr id="30" name="Right Arrow 29">
+            <a:extLst>
+              <a:ext uri="{FF2B5EF4-FFF2-40B4-BE49-F238E27FC236}">
+                <a16:creationId xmlns:a16="http://schemas.microsoft.com/office/drawing/2014/main" id="{1047004B-253B-9CC6-8B24-2F866D686566}"/>
+              </a:ext>
+            </a:extLst>
+          </p:cNvPr>
+          <p:cNvSpPr/>
+          <p:nvPr/>
+        </p:nvSpPr>
+        <p:spPr>
+          <a:xfrm rot="19419849">
+            <a:off x="1657498" y="2230109"/>
+            <a:ext cx="1025495" cy="529839"/>
+          </a:xfrm>
+          <a:prstGeom prst="rightArrow">
+            <a:avLst/>
+          </a:prstGeom>
+        </p:spPr>
+        <p:style>
+          <a:lnRef idx="2">
+            <a:schemeClr val="accent1">
+              <a:shade val="15000"/>
+            </a:schemeClr>
+          </a:lnRef>
+          <a:fillRef idx="1">
+            <a:schemeClr val="accent1"/>
+          </a:fillRef>
+          <a:effectRef idx="0">
+            <a:schemeClr val="accent1"/>
+          </a:effectRef>
+          <a:fontRef idx="minor">
+            <a:schemeClr val="lt1"/>
+          </a:fontRef>
+        </p:style>
+        <p:txBody>
+          <a:bodyPr rtlCol="0" anchor="ctr"/>
+          <a:lstStyle/>
+          <a:p>
+            <a:pPr algn="ctr"/>
+            <a:endParaRPr lang="en-US"/>
+          </a:p>
+        </p:txBody>
+      </p:sp>
+      <p:sp>
+        <p:nvSpPr>
+          <p:cNvPr id="31" name="Right Arrow 30">
+            <a:extLst>
+              <a:ext uri="{FF2B5EF4-FFF2-40B4-BE49-F238E27FC236}">
+                <a16:creationId xmlns:a16="http://schemas.microsoft.com/office/drawing/2014/main" id="{8D7E394A-7EE0-A9DA-D6B0-17E5EDD5EAB5}"/>
+              </a:ext>
+            </a:extLst>
+          </p:cNvPr>
+          <p:cNvSpPr/>
+          <p:nvPr/>
+        </p:nvSpPr>
+        <p:spPr>
+          <a:xfrm rot="5400000">
+            <a:off x="3820459" y="3637800"/>
+            <a:ext cx="717906" cy="554994"/>
+          </a:xfrm>
+          <a:prstGeom prst="rightArrow">
+            <a:avLst/>
+          </a:prstGeom>
+        </p:spPr>
+        <p:style>
+          <a:lnRef idx="2">
+            <a:schemeClr val="accent1">
+              <a:shade val="15000"/>
+            </a:schemeClr>
+          </a:lnRef>
+          <a:fillRef idx="1">
+            <a:schemeClr val="accent1"/>
+          </a:fillRef>
+          <a:effectRef idx="0">
+            <a:schemeClr val="accent1"/>
+          </a:effectRef>
+          <a:fontRef idx="minor">
+            <a:schemeClr val="lt1"/>
+          </a:fontRef>
+        </p:style>
+        <p:txBody>
+          <a:bodyPr rtlCol="0" anchor="ctr"/>
+          <a:lstStyle/>
+          <a:p>
+            <a:pPr algn="ctr"/>
+            <a:endParaRPr lang="en-US"/>
+          </a:p>
+        </p:txBody>
+      </p:sp>
+      <p:sp>
+        <p:nvSpPr>
+          <p:cNvPr id="33" name="Rectangle 32">
+            <a:extLst>
+              <a:ext uri="{FF2B5EF4-FFF2-40B4-BE49-F238E27FC236}">
+                <a16:creationId xmlns:a16="http://schemas.microsoft.com/office/drawing/2014/main" id="{C375490E-3D0B-FF10-98AB-5B9BC5C26EED}"/>
+              </a:ext>
+            </a:extLst>
+          </p:cNvPr>
+          <p:cNvSpPr/>
+          <p:nvPr/>
+        </p:nvSpPr>
+        <p:spPr>
+          <a:xfrm>
+            <a:off x="7002398" y="3418295"/>
+            <a:ext cx="3951340" cy="1073935"/>
+          </a:xfrm>
+          <a:prstGeom prst="rect">
+            <a:avLst/>
+          </a:prstGeom>
+          <a:solidFill>
+            <a:schemeClr val="accent3">
+              <a:lumMod val="60000"/>
+              <a:lumOff val="40000"/>
+            </a:schemeClr>
+          </a:solidFill>
+        </p:spPr>
+        <p:style>
+          <a:lnRef idx="2">
+            <a:schemeClr val="accent1">
+              <a:shade val="15000"/>
+            </a:schemeClr>
+          </a:lnRef>
+          <a:fillRef idx="1">
+            <a:schemeClr val="accent1"/>
+          </a:fillRef>
+          <a:effectRef idx="0">
+            <a:schemeClr val="accent1"/>
+          </a:effectRef>
+          <a:fontRef idx="minor">
+            <a:schemeClr val="lt1"/>
+          </a:fontRef>
+        </p:style>
+        <p:txBody>
+          <a:bodyPr rtlCol="0" anchor="ctr"/>
+          <a:lstStyle/>
+          <a:p>
+            <a:pPr algn="ctr"/>
+            <a:r>
+              <a:rPr lang="en-US" dirty="0"/>
+              <a:t>If a standardized name represents majority of the cluster member assign it as the standardized name for all cluster members.</a:t>
+            </a:r>
+          </a:p>
+        </p:txBody>
+      </p:sp>
+      <p:sp>
+        <p:nvSpPr>
+          <p:cNvPr id="34" name="Rectangle 33">
+            <a:extLst>
+              <a:ext uri="{FF2B5EF4-FFF2-40B4-BE49-F238E27FC236}">
+                <a16:creationId xmlns:a16="http://schemas.microsoft.com/office/drawing/2014/main" id="{99BD2896-22CA-7080-D08F-00B23282629E}"/>
+              </a:ext>
+            </a:extLst>
+          </p:cNvPr>
+          <p:cNvSpPr/>
+          <p:nvPr/>
+        </p:nvSpPr>
+        <p:spPr>
+          <a:xfrm>
+            <a:off x="7030939" y="4701874"/>
+            <a:ext cx="3951339" cy="860083"/>
+          </a:xfrm>
+          <a:prstGeom prst="rect">
+            <a:avLst/>
+          </a:prstGeom>
+          <a:solidFill>
+            <a:schemeClr val="accent3">
+              <a:lumMod val="60000"/>
+              <a:lumOff val="40000"/>
+            </a:schemeClr>
+          </a:solidFill>
+        </p:spPr>
+        <p:style>
+          <a:lnRef idx="2">
+            <a:schemeClr val="accent1">
+              <a:shade val="15000"/>
+            </a:schemeClr>
+          </a:lnRef>
+          <a:fillRef idx="1">
+            <a:schemeClr val="accent1"/>
+          </a:fillRef>
+          <a:effectRef idx="0">
+            <a:schemeClr val="accent1"/>
+          </a:effectRef>
+          <a:fontRef idx="minor">
+            <a:schemeClr val="lt1"/>
+          </a:fontRef>
+        </p:style>
+        <p:txBody>
+          <a:bodyPr rtlCol="0" anchor="ctr"/>
+          <a:lstStyle/>
+          <a:p>
+            <a:pPr algn="ctr"/>
+            <a:r>
+              <a:rPr lang="en-US" dirty="0"/>
+              <a:t>Otherwise, assign cluster members to nearest standardized term</a:t>
+            </a:r>
+          </a:p>
+        </p:txBody>
+      </p:sp>
+      <p:sp>
+        <p:nvSpPr>
+          <p:cNvPr id="36" name="Right Arrow 35">
+            <a:extLst>
+              <a:ext uri="{FF2B5EF4-FFF2-40B4-BE49-F238E27FC236}">
+                <a16:creationId xmlns:a16="http://schemas.microsoft.com/office/drawing/2014/main" id="{4DF430CE-88CC-33B4-4EB9-B61CDC7A4A17}"/>
+              </a:ext>
+            </a:extLst>
+          </p:cNvPr>
+          <p:cNvSpPr/>
+          <p:nvPr/>
+        </p:nvSpPr>
+        <p:spPr>
+          <a:xfrm>
+            <a:off x="6132670" y="4398806"/>
+            <a:ext cx="717906" cy="554994"/>
+          </a:xfrm>
+          <a:prstGeom prst="rightArrow">
+            <a:avLst/>
+          </a:prstGeom>
+        </p:spPr>
+        <p:style>
+          <a:lnRef idx="2">
+            <a:schemeClr val="accent1">
+              <a:shade val="15000"/>
+            </a:schemeClr>
+          </a:lnRef>
+          <a:fillRef idx="1">
+            <a:schemeClr val="accent1"/>
+          </a:fillRef>
+          <a:effectRef idx="0">
+            <a:schemeClr val="accent1"/>
+          </a:effectRef>
+          <a:fontRef idx="minor">
+            <a:schemeClr val="lt1"/>
+          </a:fontRef>
+        </p:style>
+        <p:txBody>
+          <a:bodyPr rtlCol="0" anchor="ctr"/>
+          <a:lstStyle/>
+          <a:p>
+            <a:pPr algn="ctr"/>
+            <a:endParaRPr lang="en-US"/>
+          </a:p>
+        </p:txBody>
+      </p:sp>
+    </p:spTree>
+    <p:extLst>
+      <p:ext uri="{BB962C8B-B14F-4D97-AF65-F5344CB8AC3E}">
+        <p14:creationId xmlns:p14="http://schemas.microsoft.com/office/powerpoint/2010/main" val="3115427848"/>
+      </p:ext>
+    </p:extLst>
+  </p:cSld>
+  <p:clrMapOvr>
+    <a:masterClrMapping/>
+  </p:clrMapOvr>
+</p:sld>
+</file>
+
+<file path=ppt/slides/slide14.xml><?xml version="1.0" encoding="utf-8"?>
+<p:sld xmlns:a="http://schemas.openxmlformats.org/drawingml/2006/main" xmlns:r="http://schemas.openxmlformats.org/officeDocument/2006/relationships" xmlns:p="http://schemas.openxmlformats.org/presentationml/2006/main">
+  <p:cSld>
+    <p:spTree>
+      <p:nvGrpSpPr>
+        <p:cNvPr id="1" name=""/>
+        <p:cNvGrpSpPr/>
+        <p:nvPr/>
+      </p:nvGrpSpPr>
+      <p:grpSpPr>
+        <a:xfrm>
+          <a:off x="0" y="0"/>
+          <a:ext cx="0" cy="0"/>
+          <a:chOff x="0" y="0"/>
+          <a:chExt cx="0" cy="0"/>
+        </a:xfrm>
+      </p:grpSpPr>
+      <p:sp>
+        <p:nvSpPr>
+          <p:cNvPr id="2" name="Slide Number Placeholder 1">
+            <a:extLst>
+              <a:ext uri="{FF2B5EF4-FFF2-40B4-BE49-F238E27FC236}">
+                <a16:creationId xmlns:a16="http://schemas.microsoft.com/office/drawing/2014/main" id="{44270733-E29D-FB26-4D1C-A42A2AC40AEC}"/>
+              </a:ext>
+            </a:extLst>
+          </p:cNvPr>
+          <p:cNvSpPr>
+            <a:spLocks noGrp="1"/>
+          </p:cNvSpPr>
+          <p:nvPr>
+            <p:ph type="sldNum" sz="quarter" idx="12"/>
+          </p:nvPr>
+        </p:nvSpPr>
+        <p:spPr/>
+        <p:txBody>
+          <a:bodyPr/>
+          <a:lstStyle/>
+          <a:p>
+            <a:fld id="{AD40181A-01B0-4CB8-8614-1473649F6741}" type="slidenum">
+              <a:rPr lang="en-US" smtClean="0"/>
+              <a:pPr/>
+              <a:t>14</a:t>
+            </a:fld>
+            <a:endParaRPr lang="en-US" dirty="0"/>
+          </a:p>
+        </p:txBody>
+      </p:sp>
+      <p:sp>
+        <p:nvSpPr>
+          <p:cNvPr id="4" name="Title 2">
+            <a:extLst>
+              <a:ext uri="{FF2B5EF4-FFF2-40B4-BE49-F238E27FC236}">
+                <a16:creationId xmlns:a16="http://schemas.microsoft.com/office/drawing/2014/main" id="{6E00D5E8-B1F0-2EBD-8ABB-6D3227812B99}"/>
+              </a:ext>
+            </a:extLst>
+          </p:cNvPr>
+          <p:cNvSpPr>
+            <a:spLocks noGrp="1"/>
+          </p:cNvSpPr>
+          <p:nvPr>
+            <p:ph type="title"/>
+          </p:nvPr>
+        </p:nvSpPr>
+        <p:spPr>
+          <a:xfrm>
+            <a:off x="0" y="-294409"/>
+            <a:ext cx="11874374" cy="1279750"/>
+          </a:xfrm>
+        </p:spPr>
+        <p:txBody>
+          <a:bodyPr/>
+          <a:lstStyle/>
+          <a:p>
+            <a:r>
+              <a:rPr lang="en-US" dirty="0"/>
+              <a:t>CANTOS : Tumor Name Standardization phase</a:t>
+            </a:r>
+          </a:p>
+        </p:txBody>
+      </p:sp>
+    </p:spTree>
+    <p:extLst>
+      <p:ext uri="{BB962C8B-B14F-4D97-AF65-F5344CB8AC3E}">
+        <p14:creationId xmlns:p14="http://schemas.microsoft.com/office/powerpoint/2010/main" val="875706484"/>
       </p:ext>
     </p:extLst>
   </p:cSld>
@@ -5932,6 +8387,165 @@
             <a:ext cx="1025495" cy="529839"/>
           </a:xfrm>
           <a:prstGeom prst="rightArrow">
+            <a:avLst/>
+          </a:prstGeom>
+        </p:spPr>
+        <p:style>
+          <a:lnRef idx="2">
+            <a:schemeClr val="accent1">
+              <a:shade val="15000"/>
+            </a:schemeClr>
+          </a:lnRef>
+          <a:fillRef idx="1">
+            <a:schemeClr val="accent1"/>
+          </a:fillRef>
+          <a:effectRef idx="0">
+            <a:schemeClr val="accent1"/>
+          </a:effectRef>
+          <a:fontRef idx="minor">
+            <a:schemeClr val="lt1"/>
+          </a:fontRef>
+        </p:style>
+        <p:txBody>
+          <a:bodyPr rtlCol="0" anchor="ctr"/>
+          <a:lstStyle/>
+          <a:p>
+            <a:pPr algn="ctr"/>
+            <a:endParaRPr lang="en-US"/>
+          </a:p>
+        </p:txBody>
+      </p:sp>
+      <p:pic>
+        <p:nvPicPr>
+          <p:cNvPr id="23" name="Graphic 22" descr="Document outline">
+            <a:extLst>
+              <a:ext uri="{FF2B5EF4-FFF2-40B4-BE49-F238E27FC236}">
+                <a16:creationId xmlns:a16="http://schemas.microsoft.com/office/drawing/2014/main" id="{1D642C46-64FD-E1CF-991E-3E2C3B5A90DE}"/>
+              </a:ext>
+            </a:extLst>
+          </p:cNvPr>
+          <p:cNvPicPr>
+            <a:picLocks noChangeAspect="1"/>
+          </p:cNvPicPr>
+          <p:nvPr/>
+        </p:nvPicPr>
+        <p:blipFill>
+          <a:blip r:embed="rId3">
+            <a:extLst>
+              <a:ext uri="{96DAC541-7B7A-43D3-8B79-37D633B846F1}">
+                <asvg:svgBlip xmlns:asvg="http://schemas.microsoft.com/office/drawing/2016/SVG/main" r:embed="rId4"/>
+              </a:ext>
+            </a:extLst>
+          </a:blip>
+          <a:stretch>
+            <a:fillRect/>
+          </a:stretch>
+        </p:blipFill>
+        <p:spPr>
+          <a:xfrm>
+            <a:off x="10203646" y="3771628"/>
+            <a:ext cx="1122081" cy="1122081"/>
+          </a:xfrm>
+          <a:prstGeom prst="rect">
+            <a:avLst/>
+          </a:prstGeom>
+        </p:spPr>
+      </p:pic>
+      <p:sp>
+        <p:nvSpPr>
+          <p:cNvPr id="24" name="TextBox 23">
+            <a:extLst>
+              <a:ext uri="{FF2B5EF4-FFF2-40B4-BE49-F238E27FC236}">
+                <a16:creationId xmlns:a16="http://schemas.microsoft.com/office/drawing/2014/main" id="{A7D4910C-3261-8D5E-DF44-BD78E4DFD445}"/>
+              </a:ext>
+            </a:extLst>
+          </p:cNvPr>
+          <p:cNvSpPr txBox="1"/>
+          <p:nvPr/>
+        </p:nvSpPr>
+        <p:spPr>
+          <a:xfrm>
+            <a:off x="9825967" y="4900084"/>
+            <a:ext cx="1877437" cy="646331"/>
+          </a:xfrm>
+          <a:prstGeom prst="rect">
+            <a:avLst/>
+          </a:prstGeom>
+          <a:noFill/>
+        </p:spPr>
+        <p:txBody>
+          <a:bodyPr wrap="none" rtlCol="0">
+            <a:spAutoFit/>
+          </a:bodyPr>
+          <a:lstStyle/>
+          <a:p>
+            <a:r>
+              <a:rPr lang="en-US" dirty="0">
+                <a:solidFill>
+                  <a:schemeClr val="bg2">
+                    <a:lumMod val="50000"/>
+                  </a:schemeClr>
+                </a:solidFill>
+              </a:rPr>
+              <a:t>Unstandardized </a:t>
+            </a:r>
+            <a:br>
+              <a:rPr lang="en-US" dirty="0">
+                <a:solidFill>
+                  <a:schemeClr val="bg2">
+                    <a:lumMod val="50000"/>
+                  </a:schemeClr>
+                </a:solidFill>
+              </a:rPr>
+            </a:br>
+            <a:r>
+              <a:rPr lang="en-US" dirty="0">
+                <a:solidFill>
+                  <a:schemeClr val="bg2">
+                    <a:lumMod val="50000"/>
+                  </a:schemeClr>
+                </a:solidFill>
+              </a:rPr>
+              <a:t>Tumor </a:t>
+            </a:r>
+            <a:r>
+              <a:rPr lang="en-US" dirty="0" err="1">
+                <a:solidFill>
+                  <a:schemeClr val="bg2">
+                    <a:lumMod val="50000"/>
+                  </a:schemeClr>
+                </a:solidFill>
+              </a:rPr>
+              <a:t>List.csv</a:t>
+            </a:r>
+            <a:endParaRPr lang="en-US" dirty="0">
+              <a:solidFill>
+                <a:schemeClr val="bg2">
+                  <a:lumMod val="50000"/>
+                </a:schemeClr>
+              </a:solidFill>
+            </a:endParaRPr>
+          </a:p>
+        </p:txBody>
+      </p:sp>
+      <p:sp>
+        <p:nvSpPr>
+          <p:cNvPr id="25" name="Down Arrow 24">
+            <a:extLst>
+              <a:ext uri="{FF2B5EF4-FFF2-40B4-BE49-F238E27FC236}">
+                <a16:creationId xmlns:a16="http://schemas.microsoft.com/office/drawing/2014/main" id="{7908E861-195C-F6AA-4218-CCC0E64A857F}"/>
+              </a:ext>
+            </a:extLst>
+          </p:cNvPr>
+          <p:cNvSpPr/>
+          <p:nvPr/>
+        </p:nvSpPr>
+        <p:spPr>
+          <a:xfrm>
+            <a:off x="10486690" y="3442087"/>
+            <a:ext cx="304800" cy="369333"/>
+          </a:xfrm>
+          <a:prstGeom prst="downArrow">
             <a:avLst/>
           </a:prstGeom>
         </p:spPr>

</xml_diff>

<commit_message>
update cantos pptwith levenshtein distances
</commit_message>
<xml_diff>
--- a/presentations/CANTOS_PPT.pptx
+++ b/presentations/CANTOS_PPT.pptx
@@ -1803,8 +1803,8 @@
         </p:nvSpPr>
         <p:spPr>
           <a:xfrm>
-            <a:off x="0" y="-294409"/>
-            <a:ext cx="11874374" cy="1279750"/>
+            <a:off x="-1" y="-294409"/>
+            <a:ext cx="12398829" cy="1262474"/>
           </a:xfrm>
         </p:spPr>
         <p:txBody>
@@ -1813,7 +1813,7 @@
           <a:p>
             <a:r>
               <a:rPr lang="en-US" dirty="0"/>
-              <a:t>CANTOS : Tumor Name Standardization phase</a:t>
+              <a:t>CANTOS Phase 2: Tumor Name Standardization</a:t>
             </a:r>
           </a:p>
         </p:txBody>
@@ -2435,7 +2435,7 @@
         <p:spPr>
           <a:xfrm>
             <a:off x="0" y="-294409"/>
-            <a:ext cx="11874374" cy="1279750"/>
+            <a:ext cx="12192000" cy="1316304"/>
           </a:xfrm>
         </p:spPr>
         <p:txBody>
@@ -2444,7 +2444,7 @@
           <a:p>
             <a:r>
               <a:rPr lang="en-US" dirty="0"/>
-              <a:t>CANTOS : Tumor Name Standardization phase</a:t>
+              <a:t>CANTOS Phase 2: Tumor Name Standardization</a:t>
             </a:r>
           </a:p>
         </p:txBody>
@@ -2684,7 +2684,7 @@
             <a:pPr algn="ctr"/>
             <a:r>
               <a:rPr lang="en-US" dirty="0"/>
-              <a:t>Compute edit distance: Cosine, </a:t>
+              <a:t>Compute edit distance matrices: Cosine, </a:t>
             </a:r>
             <a:r>
               <a:rPr lang="en-US" dirty="0" err="1"/>
@@ -3454,7 +3454,7 @@
         <p:spPr>
           <a:xfrm>
             <a:off x="87086" y="21771"/>
-            <a:ext cx="10651402" cy="1143000"/>
+            <a:ext cx="12104914" cy="892629"/>
           </a:xfrm>
         </p:spPr>
         <p:txBody>
@@ -3463,7 +3463,7 @@
           <a:p>
             <a:r>
               <a:rPr lang="en-US" dirty="0"/>
-              <a:t>Tumor Name Standardization		</a:t>
+              <a:t>CANTOS Phase 2: Tumor Name Standardization</a:t>
             </a:r>
           </a:p>
         </p:txBody>
@@ -3547,6 +3547,83 @@
               </a:rPr>
               <a:t> etc. </a:t>
             </a:r>
+          </a:p>
+          <a:p>
+            <a:pPr lvl="1" algn="just"/>
+            <a:r>
+              <a:rPr lang="en-US" sz="1400" dirty="0">
+                <a:solidFill>
+                  <a:schemeClr val="tx1"/>
+                </a:solidFill>
+                <a:latin typeface="+mn-lt"/>
+              </a:rPr>
+              <a:t>Example : Lung Cancer  and Liver Cancer :  </a:t>
+            </a:r>
+            <a:r>
+              <a:rPr lang="en-US" sz="1400" dirty="0" err="1">
+                <a:solidFill>
+                  <a:schemeClr val="tx1"/>
+                </a:solidFill>
+                <a:latin typeface="+mn-lt"/>
+              </a:rPr>
+              <a:t>Levenshtein</a:t>
+            </a:r>
+            <a:r>
+              <a:rPr lang="en-US" sz="1400" dirty="0">
+                <a:solidFill>
+                  <a:schemeClr val="tx1"/>
+                </a:solidFill>
+                <a:latin typeface="+mn-lt"/>
+              </a:rPr>
+              <a:t> Distance =4</a:t>
+            </a:r>
+          </a:p>
+          <a:p>
+            <a:pPr lvl="1" algn="just"/>
+            <a:r>
+              <a:rPr lang="en-US" sz="1400" dirty="0">
+                <a:solidFill>
+                  <a:schemeClr val="tx1"/>
+                </a:solidFill>
+                <a:latin typeface="+mn-lt"/>
+                <a:cs typeface="+mn-cs"/>
+              </a:rPr>
+              <a:t>Example:  Lung Cancer and Non Smal</a:t>
+            </a:r>
+            <a:r>
+              <a:rPr lang="en-US" sz="1400" dirty="0">
+                <a:solidFill>
+                  <a:schemeClr val="tx1"/>
+                </a:solidFill>
+                <a:latin typeface="+mn-lt"/>
+              </a:rPr>
+              <a:t>l Cell Lung Cancer:  </a:t>
+            </a:r>
+            <a:r>
+              <a:rPr lang="en-US" sz="1400" dirty="0" err="1">
+                <a:solidFill>
+                  <a:schemeClr val="tx1"/>
+                </a:solidFill>
+                <a:latin typeface="+mn-lt"/>
+              </a:rPr>
+              <a:t>Levenshtein</a:t>
+            </a:r>
+            <a:r>
+              <a:rPr lang="en-US" sz="1400" dirty="0">
+                <a:solidFill>
+                  <a:schemeClr val="tx1"/>
+                </a:solidFill>
+                <a:latin typeface="+mn-lt"/>
+              </a:rPr>
+              <a:t> Distance =14</a:t>
+            </a:r>
+            <a:endParaRPr lang="en-US" sz="1400" dirty="0">
+              <a:solidFill>
+                <a:schemeClr val="tx1"/>
+              </a:solidFill>
+              <a:latin typeface="+mn-lt"/>
+              <a:cs typeface="+mn-cs"/>
+            </a:endParaRPr>
           </a:p>
           <a:p>
             <a:pPr algn="just"/>
@@ -3842,8 +3919,8 @@
         </p:nvSpPr>
         <p:spPr>
           <a:xfrm>
-            <a:off x="0" y="-294409"/>
-            <a:ext cx="11874374" cy="1279750"/>
+            <a:off x="0" y="-294410"/>
+            <a:ext cx="12192000" cy="1414237"/>
           </a:xfrm>
         </p:spPr>
         <p:txBody>
@@ -3852,7 +3929,7 @@
           <a:p>
             <a:r>
               <a:rPr lang="en-US" dirty="0"/>
-              <a:t>CANTOS : Tumor Name Standardization phase</a:t>
+              <a:t>CANTOS phase 2: Tumor Name Standardization</a:t>
             </a:r>
           </a:p>
         </p:txBody>
@@ -4092,7 +4169,7 @@
             <a:pPr algn="ctr"/>
             <a:r>
               <a:rPr lang="en-US" dirty="0"/>
-              <a:t>Compute embedding distance distance</a:t>
+              <a:t>Compute embedding distance matrices</a:t>
             </a:r>
           </a:p>
         </p:txBody>
@@ -5050,14 +5127,14 @@
           <p:nvPr>
             <p:extLst>
               <p:ext uri="{D42A27DB-BD31-4B8C-83A1-F6EECF244321}">
-                <p14:modId xmlns:p14="http://schemas.microsoft.com/office/powerpoint/2010/main" val="1053260055"/>
+                <p14:modId xmlns:p14="http://schemas.microsoft.com/office/powerpoint/2010/main" val="2949739579"/>
               </p:ext>
             </p:extLst>
           </p:nvPr>
         </p:nvGraphicFramePr>
         <p:xfrm>
-          <a:off x="1801585" y="2409242"/>
-          <a:ext cx="8588829" cy="3566160"/>
+          <a:off x="1217259" y="2420128"/>
+          <a:ext cx="10657115" cy="3566160"/>
         </p:xfrm>
         <a:graphic>
           <a:graphicData uri="http://schemas.openxmlformats.org/drawingml/2006/table">
@@ -5066,21 +5143,21 @@
                 <a:tableStyleId>{5C22544A-7EE6-4342-B048-85BDC9FD1C3A}</a:tableStyleId>
               </a:tblPr>
               <a:tblGrid>
-                <a:gridCol w="3493581">
+                <a:gridCol w="4334875">
                   <a:extLst>
                     <a:ext uri="{9D8B030D-6E8A-4147-A177-3AD203B41FA5}">
                       <a16:colId xmlns:a16="http://schemas.microsoft.com/office/drawing/2014/main" val="4253658004"/>
                     </a:ext>
                   </a:extLst>
                 </a:gridCol>
-                <a:gridCol w="2547624">
+                <a:gridCol w="3161120">
                   <a:extLst>
                     <a:ext uri="{9D8B030D-6E8A-4147-A177-3AD203B41FA5}">
                       <a16:colId xmlns:a16="http://schemas.microsoft.com/office/drawing/2014/main" val="987428443"/>
                     </a:ext>
                   </a:extLst>
                 </a:gridCol>
-                <a:gridCol w="2547624">
+                <a:gridCol w="3161120">
                   <a:extLst>
                     <a:ext uri="{9D8B030D-6E8A-4147-A177-3AD203B41FA5}">
                       <a16:colId xmlns:a16="http://schemas.microsoft.com/office/drawing/2014/main" val="544761200"/>
@@ -6307,6 +6384,13 @@
                         <a:rPr lang="en-US" sz="1000" dirty="0" err="1"/>
                         <a:t>clinicalBERT</a:t>
                       </a:r>
+                      <a:endParaRPr lang="en-US" sz="1000" dirty="0"/>
+                    </a:p>
+                    <a:p>
+                      <a:pPr marL="171450" indent="-171450" algn="l">
+                        <a:buFont typeface="Arial" panose="020B0604020202020204" pitchFamily="34" charset="0"/>
+                        <a:buChar char="•"/>
+                      </a:pPr>
                       <a:endParaRPr lang="en-US" sz="1000" dirty="0"/>
                     </a:p>
                   </a:txBody>
@@ -6759,7 +6843,7 @@
           <p:nvPr>
             <p:extLst>
               <p:ext uri="{D42A27DB-BD31-4B8C-83A1-F6EECF244321}">
-                <p14:modId xmlns:p14="http://schemas.microsoft.com/office/powerpoint/2010/main" val="1524688020"/>
+                <p14:modId xmlns:p14="http://schemas.microsoft.com/office/powerpoint/2010/main" val="3961978129"/>
               </p:ext>
             </p:extLst>
           </p:nvPr>
@@ -9691,11 +9775,11 @@
                           <a:effectLst/>
                           <a:uLnTx/>
                           <a:uFillTx/>
-                          <a:latin typeface="Georgia"/>
-                          <a:ea typeface="+mn-ea"/>
-                          <a:cs typeface="+mn-cs"/>
-                        </a:rPr>
-                        <a:t>Text-Matching</a:t>
+                          <a:latin typeface="+mn-lt"/>
+                          <a:ea typeface="+mn-ea"/>
+                          <a:cs typeface="+mn-cs"/>
+                        </a:rPr>
+                        <a:t>Edit Distance</a:t>
                       </a:r>
                     </a:p>
                   </a:txBody>
@@ -10239,7 +10323,7 @@
                         <a:defRPr/>
                       </a:pPr>
                       <a:r>
-                        <a:rPr kumimoji="0" lang="en-US" sz="800" b="0" i="0" u="none" strike="noStrike" kern="1200" cap="none" spc="0" normalizeH="0" baseline="0">
+                        <a:rPr kumimoji="0" lang="en-US" sz="800" b="0" i="0" u="none" strike="noStrike" kern="1200" cap="none" spc="0" normalizeH="0" baseline="0" dirty="0">
                           <a:ln>
                             <a:noFill/>
                           </a:ln>
@@ -10249,11 +10333,11 @@
                           <a:effectLst/>
                           <a:uLnTx/>
                           <a:uFillTx/>
-                          <a:latin typeface="Georgia"/>
-                          <a:ea typeface="+mn-ea"/>
-                          <a:cs typeface="+mn-cs"/>
-                        </a:rPr>
-                        <a:t>Text-Matching</a:t>
+                          <a:latin typeface="+mn-lt"/>
+                          <a:ea typeface="+mn-ea"/>
+                          <a:cs typeface="+mn-cs"/>
+                        </a:rPr>
+                        <a:t>Edit Distance</a:t>
                       </a:r>
                     </a:p>
                   </a:txBody>
@@ -10375,7 +10459,7 @@
                         <a:defRPr/>
                       </a:pPr>
                       <a:r>
-                        <a:rPr kumimoji="0" lang="en-US" sz="800" b="0" i="0" u="none" strike="noStrike" kern="1200" cap="none" spc="0" normalizeH="0" baseline="0">
+                        <a:rPr kumimoji="0" lang="en-US" sz="800" b="0" i="0" u="none" strike="noStrike" kern="1200" cap="none" spc="0" normalizeH="0" baseline="0" dirty="0">
                           <a:ln>
                             <a:noFill/>
                           </a:ln>
@@ -10385,11 +10469,11 @@
                           <a:effectLst/>
                           <a:uLnTx/>
                           <a:uFillTx/>
-                          <a:latin typeface="Georgia"/>
-                          <a:ea typeface="+mn-ea"/>
-                          <a:cs typeface="+mn-cs"/>
-                        </a:rPr>
-                        <a:t>Text-Matching</a:t>
+                          <a:latin typeface="+mn-lt"/>
+                          <a:ea typeface="+mn-ea"/>
+                          <a:cs typeface="+mn-cs"/>
+                        </a:rPr>
+                        <a:t>Edit Distance</a:t>
                       </a:r>
                     </a:p>
                   </a:txBody>
@@ -10559,7 +10643,7 @@
                         <a:defRPr/>
                       </a:pPr>
                       <a:r>
-                        <a:rPr kumimoji="0" lang="en-US" sz="800" b="0" i="0" u="none" strike="noStrike" kern="1200" cap="none" spc="0" normalizeH="0" baseline="0">
+                        <a:rPr kumimoji="0" lang="en-US" sz="800" b="0" i="0" u="none" strike="noStrike" kern="1200" cap="none" spc="0" normalizeH="0" baseline="0" dirty="0">
                           <a:ln>
                             <a:noFill/>
                           </a:ln>
@@ -10569,11 +10653,11 @@
                           <a:effectLst/>
                           <a:uLnTx/>
                           <a:uFillTx/>
-                          <a:latin typeface="Georgia"/>
-                          <a:ea typeface="+mn-ea"/>
-                          <a:cs typeface="+mn-cs"/>
-                        </a:rPr>
-                        <a:t>Text-Matching</a:t>
+                          <a:latin typeface="+mn-lt"/>
+                          <a:ea typeface="+mn-ea"/>
+                          <a:cs typeface="+mn-cs"/>
+                        </a:rPr>
+                        <a:t>Edit Distance</a:t>
                       </a:r>
                     </a:p>
                   </a:txBody>
@@ -10872,11 +10956,11 @@
                           <a:effectLst/>
                           <a:uLnTx/>
                           <a:uFillTx/>
-                          <a:latin typeface="Georgia"/>
-                          <a:ea typeface="+mn-ea"/>
-                          <a:cs typeface="+mn-cs"/>
-                        </a:rPr>
-                        <a:t>Text-Matching</a:t>
+                          <a:latin typeface="+mn-lt"/>
+                          <a:ea typeface="+mn-ea"/>
+                          <a:cs typeface="+mn-cs"/>
+                        </a:rPr>
+                        <a:t>Edit Distance</a:t>
                       </a:r>
                     </a:p>
                   </a:txBody>
@@ -12208,7 +12292,7 @@
           <p:nvPr>
             <p:extLst>
               <p:ext uri="{D42A27DB-BD31-4B8C-83A1-F6EECF244321}">
-                <p14:modId xmlns:p14="http://schemas.microsoft.com/office/powerpoint/2010/main" val="3933766387"/>
+                <p14:modId xmlns:p14="http://schemas.microsoft.com/office/powerpoint/2010/main" val="4223216739"/>
               </p:ext>
             </p:extLst>
           </p:nvPr>
@@ -15252,7 +15336,7 @@
                         <a:defRPr/>
                       </a:pPr>
                       <a:r>
-                        <a:rPr kumimoji="0" lang="en-US" sz="800" b="0" i="0" u="none" strike="noStrike" kern="1200" cap="none" spc="0" normalizeH="0" baseline="0">
+                        <a:rPr kumimoji="0" lang="en-US" sz="800" b="0" i="0" u="none" strike="noStrike" kern="1200" cap="none" spc="0" normalizeH="0" baseline="0" dirty="0">
                           <a:ln>
                             <a:noFill/>
                           </a:ln>
@@ -15266,7 +15350,7 @@
                           <a:ea typeface="+mn-ea"/>
                           <a:cs typeface="+mn-cs"/>
                         </a:rPr>
-                        <a:t>Text-Matching</a:t>
+                        <a:t>Edit Distance</a:t>
                       </a:r>
                     </a:p>
                   </a:txBody>
@@ -15388,7 +15472,7 @@
                         <a:defRPr/>
                       </a:pPr>
                       <a:r>
-                        <a:rPr kumimoji="0" lang="en-US" sz="800" b="0" i="0" u="none" strike="noStrike" kern="1200" cap="none" spc="0" normalizeH="0" baseline="0">
+                        <a:rPr kumimoji="0" lang="en-US" sz="800" b="0" i="0" u="none" strike="noStrike" kern="1200" cap="none" spc="0" normalizeH="0" baseline="0" dirty="0">
                           <a:ln>
                             <a:noFill/>
                           </a:ln>
@@ -15398,11 +15482,11 @@
                           <a:effectLst/>
                           <a:uLnTx/>
                           <a:uFillTx/>
-                          <a:latin typeface="Georgia"/>
-                          <a:ea typeface="+mn-ea"/>
-                          <a:cs typeface="+mn-cs"/>
-                        </a:rPr>
-                        <a:t>Text-Matching</a:t>
+                          <a:latin typeface="+mn-lt"/>
+                          <a:ea typeface="+mn-ea"/>
+                          <a:cs typeface="+mn-cs"/>
+                        </a:rPr>
+                        <a:t>Edit Distance</a:t>
                       </a:r>
                     </a:p>
                   </a:txBody>
@@ -15660,7 +15744,7 @@
                         <a:defRPr/>
                       </a:pPr>
                       <a:r>
-                        <a:rPr kumimoji="0" lang="en-US" sz="800" b="0" i="0" u="none" strike="noStrike" kern="1200" cap="none" spc="0" normalizeH="0" baseline="0">
+                        <a:rPr kumimoji="0" lang="en-US" sz="800" b="0" i="0" u="none" strike="noStrike" kern="1200" cap="none" spc="0" normalizeH="0" baseline="0" dirty="0">
                           <a:ln>
                             <a:noFill/>
                           </a:ln>
@@ -15670,11 +15754,11 @@
                           <a:effectLst/>
                           <a:uLnTx/>
                           <a:uFillTx/>
-                          <a:latin typeface="Georgia"/>
-                          <a:ea typeface="+mn-ea"/>
-                          <a:cs typeface="+mn-cs"/>
-                        </a:rPr>
-                        <a:t>Text-Matching</a:t>
+                          <a:latin typeface="+mn-lt"/>
+                          <a:ea typeface="+mn-ea"/>
+                          <a:cs typeface="+mn-cs"/>
+                        </a:rPr>
+                        <a:t>Edit Distance</a:t>
                       </a:r>
                     </a:p>
                   </a:txBody>
@@ -15796,7 +15880,7 @@
                         <a:defRPr/>
                       </a:pPr>
                       <a:r>
-                        <a:rPr kumimoji="0" lang="en-US" sz="800" b="0" i="0" u="none" strike="noStrike" kern="1200" cap="none" spc="0" normalizeH="0" baseline="0">
+                        <a:rPr kumimoji="0" lang="en-US" sz="800" b="0" i="0" u="none" strike="noStrike" kern="1200" cap="none" spc="0" normalizeH="0" baseline="0" dirty="0">
                           <a:ln>
                             <a:noFill/>
                           </a:ln>
@@ -15806,11 +15890,11 @@
                           <a:effectLst/>
                           <a:uLnTx/>
                           <a:uFillTx/>
-                          <a:latin typeface="Georgia"/>
-                          <a:ea typeface="+mn-ea"/>
-                          <a:cs typeface="+mn-cs"/>
-                        </a:rPr>
-                        <a:t>Text-Matching</a:t>
+                          <a:latin typeface="+mn-lt"/>
+                          <a:ea typeface="+mn-ea"/>
+                          <a:cs typeface="+mn-cs"/>
+                        </a:rPr>
+                        <a:t>Edit Distance</a:t>
                       </a:r>
                     </a:p>
                   </a:txBody>
@@ -15932,7 +16016,7 @@
                         <a:defRPr/>
                       </a:pPr>
                       <a:r>
-                        <a:rPr kumimoji="0" lang="en-US" sz="800" b="0" i="0" u="none" strike="noStrike" kern="1200" cap="none" spc="0" normalizeH="0" baseline="0">
+                        <a:rPr kumimoji="0" lang="en-US" sz="800" b="0" i="0" u="none" strike="noStrike" kern="1200" cap="none" spc="0" normalizeH="0" baseline="0" dirty="0">
                           <a:ln>
                             <a:noFill/>
                           </a:ln>
@@ -15942,11 +16026,11 @@
                           <a:effectLst/>
                           <a:uLnTx/>
                           <a:uFillTx/>
-                          <a:latin typeface="Georgia"/>
-                          <a:ea typeface="+mn-ea"/>
-                          <a:cs typeface="+mn-cs"/>
-                        </a:rPr>
-                        <a:t>Text-Matching</a:t>
+                          <a:latin typeface="+mn-lt"/>
+                          <a:ea typeface="+mn-ea"/>
+                          <a:cs typeface="+mn-cs"/>
+                        </a:rPr>
+                        <a:t>Edit Distance</a:t>
                       </a:r>
                     </a:p>
                   </a:txBody>
@@ -16068,7 +16152,7 @@
                         <a:defRPr/>
                       </a:pPr>
                       <a:r>
-                        <a:rPr kumimoji="0" lang="en-US" sz="800" b="0" i="0" u="none" strike="noStrike" kern="1200" cap="none" spc="0" normalizeH="0" baseline="0">
+                        <a:rPr kumimoji="0" lang="en-US" sz="800" b="0" i="0" u="none" strike="noStrike" kern="1200" cap="none" spc="0" normalizeH="0" baseline="0" dirty="0">
                           <a:ln>
                             <a:noFill/>
                           </a:ln>
@@ -16078,11 +16162,11 @@
                           <a:effectLst/>
                           <a:uLnTx/>
                           <a:uFillTx/>
-                          <a:latin typeface="Georgia"/>
-                          <a:ea typeface="+mn-ea"/>
-                          <a:cs typeface="+mn-cs"/>
-                        </a:rPr>
-                        <a:t>Text-Matching</a:t>
+                          <a:latin typeface="+mn-lt"/>
+                          <a:ea typeface="+mn-ea"/>
+                          <a:cs typeface="+mn-cs"/>
+                        </a:rPr>
+                        <a:t>Edit Distance</a:t>
                       </a:r>
                     </a:p>
                   </a:txBody>
@@ -18087,8 +18171,47 @@
                 </a:solidFill>
                 <a:latin typeface="Times New Roman" panose="02020603050405020304" pitchFamily="18" charset="0"/>
               </a:rPr>
-              <a:t>As CTR updates with new tumor names, CANTOS must be rerun and validated repeatedly. Additionally, the pipeline is computationally expensive and should not be used in clinical or diagnostic settings due to potential model biases and lack of regulatory validation.</a:t>
+              <a:t>As CTR updates with new tumor names, CANTOS must be rerun and validated repeatedly. </a:t>
             </a:r>
+          </a:p>
+          <a:p>
+            <a:pPr lvl="1"/>
+            <a:endParaRPr lang="en-US" sz="1400" dirty="0">
+              <a:solidFill>
+                <a:schemeClr val="tx1"/>
+              </a:solidFill>
+              <a:latin typeface="Times New Roman" panose="02020603050405020304" pitchFamily="18" charset="0"/>
+            </a:endParaRPr>
+          </a:p>
+          <a:p>
+            <a:pPr lvl="1"/>
+            <a:r>
+              <a:rPr lang="en-US" sz="1400" dirty="0">
+                <a:solidFill>
+                  <a:schemeClr val="tx1"/>
+                </a:solidFill>
+                <a:latin typeface="Times New Roman" panose="02020603050405020304" pitchFamily="18" charset="0"/>
+              </a:rPr>
+              <a:t>Standardization accuracy is not very high and thus CANTOS is solely for research analysis purposes and should not be applied in clinical or diagnostic settings.</a:t>
+            </a:r>
+          </a:p>
+          <a:p>
+            <a:pPr lvl="1"/>
+            <a:endParaRPr lang="en-US" sz="1400" dirty="0">
+              <a:solidFill>
+                <a:schemeClr val="tx1"/>
+              </a:solidFill>
+              <a:latin typeface="Times New Roman" panose="02020603050405020304" pitchFamily="18" charset="0"/>
+            </a:endParaRPr>
+          </a:p>
+          <a:p>
+            <a:pPr lvl="1"/>
+            <a:endParaRPr lang="en-US" sz="1400" dirty="0">
+              <a:solidFill>
+                <a:schemeClr val="tx1"/>
+              </a:solidFill>
+              <a:latin typeface="Times New Roman" panose="02020603050405020304" pitchFamily="18" charset="0"/>
+            </a:endParaRPr>
           </a:p>
           <a:p>
             <a:endParaRPr lang="en-US" sz="1400" b="0" i="0" u="none" strike="noStrike" dirty="0">
@@ -18237,7 +18360,12 @@
             <p:ph type="title"/>
           </p:nvPr>
         </p:nvSpPr>
-        <p:spPr/>
+        <p:spPr>
+          <a:xfrm>
+            <a:off x="0" y="-174171"/>
+            <a:ext cx="9753600" cy="1444752"/>
+          </a:xfrm>
+        </p:spPr>
         <p:txBody>
           <a:bodyPr/>
           <a:lstStyle/>
@@ -22159,7 +22287,7 @@
           <a:p>
             <a:r>
               <a:rPr lang="en-US" dirty="0"/>
-              <a:t>CANTOS : Tumor identification phase</a:t>
+              <a:t>CANTOS phase 1: Tumor identification</a:t>
             </a:r>
           </a:p>
         </p:txBody>
@@ -22973,8 +23101,8 @@
         </p:nvSpPr>
         <p:spPr>
           <a:xfrm>
-            <a:off x="87086" y="21771"/>
-            <a:ext cx="10651402" cy="1143000"/>
+            <a:off x="87085" y="21771"/>
+            <a:ext cx="12279086" cy="925286"/>
           </a:xfrm>
         </p:spPr>
         <p:txBody>
@@ -22983,7 +23111,7 @@
           <a:p>
             <a:r>
               <a:rPr lang="en-US" dirty="0"/>
-              <a:t>Tumor Name Standardization		</a:t>
+              <a:t>CANTOS PHASE 2: Tumor Name Standardization		</a:t>
             </a:r>
           </a:p>
         </p:txBody>
@@ -23067,6 +23195,92 @@
               </a:rPr>
               <a:t>-Winkler etc. </a:t>
             </a:r>
+          </a:p>
+          <a:p>
+            <a:pPr lvl="1" algn="just"/>
+            <a:endParaRPr lang="en-US" sz="1400" dirty="0">
+              <a:solidFill>
+                <a:schemeClr val="tx1"/>
+              </a:solidFill>
+              <a:latin typeface="+mn-lt"/>
+            </a:endParaRPr>
+          </a:p>
+          <a:p>
+            <a:pPr lvl="1" algn="just"/>
+            <a:r>
+              <a:rPr lang="en-US" sz="1400" dirty="0">
+                <a:solidFill>
+                  <a:schemeClr val="tx1"/>
+                </a:solidFill>
+                <a:latin typeface="+mn-lt"/>
+              </a:rPr>
+              <a:t>Example : Lung Cancer  and Liver Cancer :  </a:t>
+            </a:r>
+            <a:r>
+              <a:rPr lang="en-US" sz="1400" dirty="0" err="1">
+                <a:solidFill>
+                  <a:schemeClr val="tx1"/>
+                </a:solidFill>
+                <a:latin typeface="+mn-lt"/>
+              </a:rPr>
+              <a:t>Levenshtein</a:t>
+            </a:r>
+            <a:r>
+              <a:rPr lang="en-US" sz="1400" dirty="0">
+                <a:solidFill>
+                  <a:schemeClr val="tx1"/>
+                </a:solidFill>
+                <a:latin typeface="+mn-lt"/>
+              </a:rPr>
+              <a:t> Distance =4</a:t>
+            </a:r>
+          </a:p>
+          <a:p>
+            <a:pPr lvl="1" algn="just"/>
+            <a:r>
+              <a:rPr lang="en-US" sz="1400" dirty="0">
+                <a:solidFill>
+                  <a:schemeClr val="tx1"/>
+                </a:solidFill>
+                <a:latin typeface="+mn-lt"/>
+                <a:cs typeface="+mn-cs"/>
+              </a:rPr>
+              <a:t>Example:  Lung Cancer and Non Smal</a:t>
+            </a:r>
+            <a:r>
+              <a:rPr lang="en-US" sz="1400" dirty="0">
+                <a:solidFill>
+                  <a:schemeClr val="tx1"/>
+                </a:solidFill>
+                <a:latin typeface="+mn-lt"/>
+              </a:rPr>
+              <a:t>l Cell Lung Cancer:  </a:t>
+            </a:r>
+            <a:r>
+              <a:rPr lang="en-US" sz="1400" dirty="0" err="1">
+                <a:solidFill>
+                  <a:schemeClr val="tx1"/>
+                </a:solidFill>
+                <a:latin typeface="+mn-lt"/>
+              </a:rPr>
+              <a:t>Levenshtein</a:t>
+            </a:r>
+            <a:r>
+              <a:rPr lang="en-US" sz="1400" dirty="0">
+                <a:solidFill>
+                  <a:schemeClr val="tx1"/>
+                </a:solidFill>
+                <a:latin typeface="+mn-lt"/>
+              </a:rPr>
+              <a:t> Distance =14</a:t>
+            </a:r>
+            <a:endParaRPr lang="en-US" sz="1400" dirty="0">
+              <a:solidFill>
+                <a:schemeClr val="tx1"/>
+              </a:solidFill>
+              <a:latin typeface="+mn-lt"/>
+              <a:cs typeface="+mn-cs"/>
+            </a:endParaRPr>
           </a:p>
           <a:p>
             <a:pPr algn="just"/>

</xml_diff>

<commit_message>
update cantos ppt for BIG meeting
</commit_message>
<xml_diff>
--- a/presentations/CANTOS_PPT.pptx
+++ b/presentations/CANTOS_PPT.pptx
@@ -5127,7 +5127,7 @@
           <p:nvPr>
             <p:extLst>
               <p:ext uri="{D42A27DB-BD31-4B8C-83A1-F6EECF244321}">
-                <p14:modId xmlns:p14="http://schemas.microsoft.com/office/powerpoint/2010/main" val="2949739579"/>
+                <p14:modId xmlns:p14="http://schemas.microsoft.com/office/powerpoint/2010/main" val="3056054854"/>
               </p:ext>
             </p:extLst>
           </p:nvPr>
@@ -18171,7 +18171,7 @@
                 </a:solidFill>
                 <a:latin typeface="Times New Roman" panose="02020603050405020304" pitchFamily="18" charset="0"/>
               </a:rPr>
-              <a:t>As CTR updates with new tumor names, CANTOS must be rerun and validated repeatedly. </a:t>
+              <a:t>As CTR updates with new tumor names, CANTOS must be rerun and validated repeatedly.</a:t>
             </a:r>
           </a:p>
           <a:p>
@@ -22089,7 +22089,7 @@
                 <a:latin typeface="+mn-lt"/>
                 <a:cs typeface="+mn-cs"/>
               </a:rPr>
-              <a:t>Unlike other condition names, for tumor names , we have the WHO tumor classification system which is accepted as the gold standard for tumor nomenclature among clinicians. So we evaluate standardization accuracies with respect to only the WHO tumor classification system. </a:t>
+              <a:t>Unlike other condition names, for tumor names , we have the WHO tumor classification system which is accepted as the gold standard for tumor nomenclature among clinicians. We evaluate standardization accuracies with respect to only the WHO tumor classification system. </a:t>
             </a:r>
           </a:p>
           <a:p>

</xml_diff>